<commit_message>
Update documentation and enhance outputs for Grandchild ASSIGN model
- Revised `COMPASS_DETAILED_ASSIGN_GRANDCHILD_INSTRUCTIONS.md` to include updated references and paths for related PowerPoint files, improving clarity on document locations.
- Added new markdown files for the Grandchild diagnostics, detailing the interpretation of D and H_sort metrics, enhancing understanding of the model's performance.
- Updated `statistics.json` to reflect the latest user message counts and last updated timestamps, ensuring accurate tracking of project activity.
- Introduced new empirical data files and visualizations related to team interval overlap, supporting the Grandchild model's analysis.

These changes improve the organization and clarity of the documentation, facilitating better understanding and execution of the Grandchild ASSIGN model development.
</commit_message>
<xml_diff>
--- a/3-Master_Plan/re_entry/HEROs_and_PASSes/slides/CHAR_PD17_HAND.pptx
+++ b/3-Master_Plan/re_entry/HEROs_and_PASSes/slides/CHAR_PD17_HAND.pptx
@@ -7497,181 +7497,16 @@
           <a:chExt cx="0" cy="0"/>
         </a:xfrm>
       </p:grpSpPr>
-      <p:pic>
-        <p:nvPicPr>
-          <p:cNvPr id="7" name="Picture 6">
-            <a:extLst>
-              <a:ext uri="{FF2B5EF4-FFF2-40B4-BE49-F238E27FC236}">
-                <a16:creationId xmlns:a16="http://schemas.microsoft.com/office/drawing/2014/main" id="{A3214CB9-8ABF-657F-41D2-2BE51FF9499F}"/>
-              </a:ext>
-            </a:extLst>
-          </p:cNvPr>
-          <p:cNvPicPr>
-            <a:picLocks noChangeAspect="1"/>
-          </p:cNvPicPr>
-          <p:nvPr/>
-        </p:nvPicPr>
-        <p:blipFill>
-          <a:blip r:embed="rId2"/>
-          <a:srcRect/>
-          <a:stretch/>
-        </p:blipFill>
-        <p:spPr>
-          <a:xfrm>
-            <a:off x="4551567" y="925973"/>
-            <a:ext cx="7077307" cy="5404488"/>
-          </a:xfrm>
-          <a:prstGeom prst="rect">
-            <a:avLst/>
-          </a:prstGeom>
-        </p:spPr>
-      </p:pic>
-      <mc:AlternateContent xmlns:mc="http://schemas.openxmlformats.org/markup-compatibility/2006" xmlns:a14="http://schemas.microsoft.com/office/drawing/2010/main">
-        <mc:Choice Requires="a14">
-          <p:sp>
-            <p:nvSpPr>
-              <p:cNvPr id="2" name="TextBox 1"/>
-              <p:cNvSpPr txBox="1"/>
-              <p:nvPr/>
-            </p:nvSpPr>
-            <p:spPr>
-              <a:xfrm>
-                <a:off x="384048" y="219456"/>
-                <a:ext cx="6222473" cy="418191"/>
-              </a:xfrm>
-              <a:prstGeom prst="rect">
-                <a:avLst/>
-              </a:prstGeom>
-              <a:noFill/>
-            </p:spPr>
-            <p:txBody>
-              <a:bodyPr wrap="none">
-                <a:spAutoFit/>
-              </a:bodyPr>
-              <a:lstStyle/>
-              <a:p>
-                <a:r>
-                  <a:rPr sz="2000" b="1" i="0" baseline="0" dirty="0">
-                    <a:latin typeface="Calibri"/>
-                  </a:rPr>
-                  <a:t>PD17 — Empirical team </a:t>
-                </a:r>
-                <a14:m>
-                  <m:oMath xmlns:m="http://schemas.openxmlformats.org/officeDocument/2006/math">
-                    <m:sSub>
-                      <m:sSubPr>
-                        <m:ctrlPr>
-                          <a:rPr lang="en-US" sz="2000" b="1" i="1" baseline="0" dirty="0" smtClean="0">
-                            <a:latin typeface="Cambria Math" panose="02040503050406030204" pitchFamily="18" charset="0"/>
-                          </a:rPr>
-                        </m:ctrlPr>
-                      </m:sSubPr>
-                      <m:e>
-                        <m:acc>
-                          <m:accPr>
-                            <m:chr m:val="ˆ"/>
-                            <m:ctrlPr>
-                              <a:rPr lang="en-US" sz="2000" b="1" i="1" baseline="0" dirty="0">
-                                <a:latin typeface="Cambria Math" panose="02040503050406030204" pitchFamily="18" charset="0"/>
-                              </a:rPr>
-                            </m:ctrlPr>
-                          </m:accPr>
-                          <m:e>
-                            <m:r>
-                              <a:rPr lang="en-US" sz="2000" b="1" i="0" baseline="0" dirty="0">
-                                <a:latin typeface="Cambria Math" panose="02040503050406030204" pitchFamily="18" charset="0"/>
-                              </a:rPr>
-                              <m:t>𝐴</m:t>
-                            </m:r>
-                          </m:e>
-                        </m:acc>
-                      </m:e>
-                      <m:sub>
-                        <m:r>
-                          <a:rPr lang="en-US" sz="2000" b="1" i="0" baseline="0" dirty="0">
-                            <a:latin typeface="Cambria Math" panose="02040503050406030204" pitchFamily="18" charset="0"/>
-                          </a:rPr>
-                          <m:t>𝑖</m:t>
-                        </m:r>
-                      </m:sub>
-                    </m:sSub>
-                  </m:oMath>
-                </a14:m>
-                <a:r>
-                  <a:rPr sz="2000" b="1" i="0" baseline="0" dirty="0">
-                    <a:latin typeface="Calibri"/>
-                  </a:rPr>
-                  <a:t> interval overlap (</a:t>
-                </a:r>
-                <a14:m>
-                  <m:oMath xmlns:m="http://schemas.openxmlformats.org/officeDocument/2006/math">
-                    <m:r>
-                      <a:rPr lang="en-US" sz="2000" b="1" i="0" baseline="0" dirty="0" smtClean="0">
-                        <a:latin typeface="Cambria Math" panose="02040503050406030204" pitchFamily="18" charset="0"/>
-                      </a:rPr>
-                      <m:t>𝜌</m:t>
-                    </m:r>
-                  </m:oMath>
-                </a14:m>
-                <a:r>
-                  <a:rPr sz="2000" b="1" i="0" baseline="0" dirty="0">
-                    <a:latin typeface="Calibri"/>
-                  </a:rPr>
-                  <a:t> diagnostic)</a:t>
-                </a:r>
-              </a:p>
-            </p:txBody>
-          </p:sp>
-        </mc:Choice>
-        <mc:Fallback xmlns="">
-          <p:sp>
-            <p:nvSpPr>
-              <p:cNvPr id="2" name="TextBox 1"/>
-              <p:cNvSpPr txBox="1">
-                <a:spLocks noRot="1" noChangeAspect="1" noMove="1" noResize="1" noEditPoints="1" noAdjustHandles="1" noChangeArrowheads="1" noChangeShapeType="1" noTextEdit="1"/>
-              </p:cNvSpPr>
-              <p:nvPr/>
-            </p:nvSpPr>
-            <p:spPr>
-              <a:xfrm>
-                <a:off x="384048" y="219456"/>
-                <a:ext cx="6222473" cy="418191"/>
-              </a:xfrm>
-              <a:prstGeom prst="rect">
-                <a:avLst/>
-              </a:prstGeom>
-              <a:blipFill>
-                <a:blip r:embed="rId3"/>
-                <a:stretch>
-                  <a:fillRect l="-1018" t="-14706" b="-23529"/>
-                </a:stretch>
-              </a:blipFill>
-            </p:spPr>
-            <p:txBody>
-              <a:bodyPr/>
-              <a:lstStyle/>
-              <a:p>
-                <a:r>
-                  <a:rPr lang="en-US">
-                    <a:noFill/>
-                  </a:rPr>
-                  <a:t> </a:t>
-                </a:r>
-              </a:p>
-            </p:txBody>
-          </p:sp>
-        </mc:Fallback>
-      </mc:AlternateContent>
       <p:sp>
         <p:nvSpPr>
-          <p:cNvPr id="3" name="TextBox 2"/>
+          <p:cNvPr id="2" name="TextBox 1"/>
           <p:cNvSpPr txBox="1"/>
           <p:nvPr/>
         </p:nvSpPr>
         <p:spPr>
           <a:xfrm>
-            <a:off x="384048" y="713232"/>
-            <a:ext cx="11423599" cy="246888"/>
+            <a:off x="384048" y="219456"/>
+            <a:ext cx="11423599" cy="418063680000"/>
           </a:xfrm>
           <a:prstGeom prst="rect">
             <a:avLst/>
@@ -7685,465 +7520,264 @@
           <a:lstStyle/>
           <a:p>
             <a:r>
+              <a:rPr sz="2000" b="1" i="0" baseline="0">
+                <a:latin typeface="Calibri"/>
+              </a:rPr>
+              <a:t>PD17 — Empirical team \hat{A}_{i} interval overlap (\rho diagnostic)</a:t>
+            </a:r>
+          </a:p>
+        </p:txBody>
+      </p:sp>
+      <p:sp>
+        <p:nvSpPr>
+          <p:cNvPr id="3" name="TextBox 2"/>
+          <p:cNvSpPr txBox="1"/>
+          <p:nvPr/>
+        </p:nvSpPr>
+        <p:spPr>
+          <a:xfrm>
+            <a:off x="384048" y="713232"/>
+            <a:ext cx="11423599" cy="225754387200"/>
+          </a:xfrm>
+          <a:prstGeom prst="rect">
+            <a:avLst/>
+          </a:prstGeom>
+          <a:noFill/>
+        </p:spPr>
+        <p:txBody>
+          <a:bodyPr wrap="none">
+            <a:spAutoFit/>
+          </a:bodyPr>
+          <a:lstStyle/>
+          <a:p>
+            <a:r>
               <a:rPr sz="1000" b="0" i="0" baseline="0">
                 <a:latin typeface="Calibri"/>
               </a:rPr>
-              <a:t>MBB 2011-2021 · PPM z within season · min 20 min · poolq winsor 0.01–0.99 · 6,492 team-seasons (530 CELL 8 port)</a:t>
+              <a:t>MBB 2011–2021 · PPM z · 6,492 team-seasons · H_{sort}=0.105</a:t>
             </a:r>
           </a:p>
         </p:txBody>
       </p:sp>
-      <mc:AlternateContent xmlns:mc="http://schemas.openxmlformats.org/markup-compatibility/2006" xmlns:a14="http://schemas.microsoft.com/office/drawing/2010/main">
-        <mc:Choice Requires="a14">
-          <p:sp>
-            <p:nvSpPr>
-              <p:cNvPr id="5" name="TextBox 4"/>
-              <p:cNvSpPr txBox="1"/>
-              <p:nvPr/>
-            </p:nvSpPr>
-            <p:spPr>
-              <a:xfrm>
-                <a:off x="185744" y="1280160"/>
-                <a:ext cx="4221664" cy="1697516"/>
-              </a:xfrm>
-              <a:prstGeom prst="rect">
-                <a:avLst/>
-              </a:prstGeom>
-              <a:noFill/>
-            </p:spPr>
-            <p:txBody>
-              <a:bodyPr wrap="square">
-                <a:spAutoFit/>
-              </a:bodyPr>
-              <a:lstStyle/>
-              <a:p>
-                <a:pPr>
-                  <a:lnSpc>
-                    <a:spcPct val="150000"/>
-                  </a:lnSpc>
-                  <a:buChar char="•"/>
-                </a:pPr>
-                <a:r>
-                  <a:rPr sz="1000" b="0" i="0" baseline="0" dirty="0">
-                    <a:latin typeface="Calibri"/>
-                  </a:rPr>
-                  <a:t>  Each team-season: talent window [</a:t>
-                </a:r>
-                <a14:m>
-                  <m:oMath xmlns:m="http://schemas.openxmlformats.org/officeDocument/2006/math">
-                    <m:func>
-                      <m:funcPr>
-                        <m:ctrlPr>
-                          <a:rPr lang="en-US" sz="1000" b="0" i="1" baseline="0" dirty="0" smtClean="0">
-                            <a:latin typeface="Cambria Math" panose="02040503050406030204" pitchFamily="18" charset="0"/>
-                          </a:rPr>
-                        </m:ctrlPr>
-                      </m:funcPr>
-                      <m:fName>
-                        <m:r>
-                          <m:rPr>
-                            <m:sty m:val="p"/>
-                          </m:rPr>
-                          <a:rPr lang="en-US" sz="1000" b="0" i="0" baseline="0" dirty="0">
-                            <a:latin typeface="Cambria Math" panose="02040503050406030204" pitchFamily="18" charset="0"/>
-                          </a:rPr>
-                          <m:t>min</m:t>
-                        </m:r>
-                      </m:fName>
-                      <m:e>
-                        <m:sSub>
-                          <m:sSubPr>
-                            <m:ctrlPr>
-                              <a:rPr lang="en-US" sz="1000" b="0" i="1" baseline="0" dirty="0">
-                                <a:latin typeface="Cambria Math" panose="02040503050406030204" pitchFamily="18" charset="0"/>
-                              </a:rPr>
-                            </m:ctrlPr>
-                          </m:sSubPr>
-                          <m:e>
-                            <m:acc>
-                              <m:accPr>
-                                <m:chr m:val="ˆ"/>
-                                <m:ctrlPr>
-                                  <a:rPr lang="en-US" sz="1000" b="0" i="1" baseline="0" dirty="0">
-                                    <a:latin typeface="Cambria Math" panose="02040503050406030204" pitchFamily="18" charset="0"/>
-                                  </a:rPr>
-                                </m:ctrlPr>
-                              </m:accPr>
-                              <m:e>
-                                <m:r>
-                                  <a:rPr lang="en-US" sz="1000" b="0" i="0" baseline="0" dirty="0">
-                                    <a:latin typeface="Cambria Math" panose="02040503050406030204" pitchFamily="18" charset="0"/>
-                                  </a:rPr>
-                                  <m:t>𝐴</m:t>
-                                </m:r>
-                              </m:e>
-                            </m:acc>
-                          </m:e>
-                          <m:sub>
-                            <m:r>
-                              <a:rPr lang="en-US" sz="1000" b="0" i="0" baseline="0" dirty="0">
-                                <a:latin typeface="Cambria Math" panose="02040503050406030204" pitchFamily="18" charset="0"/>
-                              </a:rPr>
-                              <m:t>𝑖</m:t>
-                            </m:r>
-                          </m:sub>
-                        </m:sSub>
-                      </m:e>
-                    </m:func>
-                    <m:r>
-                      <a:rPr lang="en-US" sz="1000" b="0" i="0" baseline="0" dirty="0">
-                        <a:latin typeface="Cambria Math" panose="02040503050406030204" pitchFamily="18" charset="0"/>
-                      </a:rPr>
-                      <m:t>,</m:t>
-                    </m:r>
-                    <m:func>
-                      <m:funcPr>
-                        <m:ctrlPr>
-                          <a:rPr lang="en-US" sz="1000" b="0" i="1" baseline="0" dirty="0">
-                            <a:latin typeface="Cambria Math" panose="02040503050406030204" pitchFamily="18" charset="0"/>
-                          </a:rPr>
-                        </m:ctrlPr>
-                      </m:funcPr>
-                      <m:fName>
-                        <m:r>
-                          <m:rPr>
-                            <m:sty m:val="p"/>
-                          </m:rPr>
-                          <a:rPr lang="en-US" sz="1000" b="0" i="0" baseline="0" dirty="0">
-                            <a:latin typeface="Cambria Math" panose="02040503050406030204" pitchFamily="18" charset="0"/>
-                          </a:rPr>
-                          <m:t>max</m:t>
-                        </m:r>
-                      </m:fName>
-                      <m:e>
-                        <m:sSub>
-                          <m:sSubPr>
-                            <m:ctrlPr>
-                              <a:rPr lang="en-US" sz="1000" b="0" i="1" baseline="0" dirty="0">
-                                <a:latin typeface="Cambria Math" panose="02040503050406030204" pitchFamily="18" charset="0"/>
-                              </a:rPr>
-                            </m:ctrlPr>
-                          </m:sSubPr>
-                          <m:e>
-                            <m:acc>
-                              <m:accPr>
-                                <m:chr m:val="ˆ"/>
-                                <m:ctrlPr>
-                                  <a:rPr lang="en-US" sz="1000" b="0" i="1" baseline="0" dirty="0">
-                                    <a:latin typeface="Cambria Math" panose="02040503050406030204" pitchFamily="18" charset="0"/>
-                                  </a:rPr>
-                                </m:ctrlPr>
-                              </m:accPr>
-                              <m:e>
-                                <m:r>
-                                  <a:rPr lang="en-US" sz="1000" b="0" i="0" baseline="0" dirty="0">
-                                    <a:latin typeface="Cambria Math" panose="02040503050406030204" pitchFamily="18" charset="0"/>
-                                  </a:rPr>
-                                  <m:t>𝐴</m:t>
-                                </m:r>
-                              </m:e>
-                            </m:acc>
-                          </m:e>
-                          <m:sub>
-                            <m:r>
-                              <a:rPr lang="en-US" sz="1000" b="0" i="0" baseline="0" dirty="0">
-                                <a:latin typeface="Cambria Math" panose="02040503050406030204" pitchFamily="18" charset="0"/>
-                              </a:rPr>
-                              <m:t>𝑖</m:t>
-                            </m:r>
-                          </m:sub>
-                        </m:sSub>
-                      </m:e>
-                    </m:func>
-                  </m:oMath>
-                </a14:m>
-                <a:r>
-                  <a:rPr sz="1000" b="0" i="0" baseline="0" dirty="0">
-                    <a:latin typeface="Calibri"/>
-                  </a:rPr>
-                  <a:t>] on PPM z.</a:t>
-                </a:r>
-              </a:p>
-              <a:p>
-                <a:pPr>
-                  <a:lnSpc>
-                    <a:spcPct val="150000"/>
-                  </a:lnSpc>
-                  <a:buChar char="•"/>
-                </a:pPr>
-                <a:r>
-                  <a:rPr sz="1000" b="0" i="0" baseline="0" dirty="0">
-                    <a:latin typeface="Calibri"/>
-                  </a:rPr>
-                  <a:t>  Coverage = how many windows cover a point on the spectrum (530 CELL 8).</a:t>
-                </a:r>
-              </a:p>
-              <a:p>
-                <a:pPr>
-                  <a:lnSpc>
-                    <a:spcPct val="150000"/>
-                  </a:lnSpc>
-                  <a:buChar char="•"/>
-                </a:pPr>
-                <a:r>
-                  <a:rPr sz="1000" b="0" i="0" baseline="0" dirty="0">
-                    <a:latin typeface="Calibri"/>
-                  </a:rPr>
-                  <a:t>  Red dashed: disjoint sort-and-chop on same player-seasons (537 B analog).</a:t>
-                </a:r>
-              </a:p>
-              <a:p>
-                <a:pPr>
-                  <a:lnSpc>
-                    <a:spcPct val="150000"/>
-                  </a:lnSpc>
-                  <a:buChar char="•"/>
-                </a:pPr>
-                <a:r>
-                  <a:rPr sz="1000" b="0" i="0" baseline="0" dirty="0">
-                    <a:latin typeface="Calibri"/>
-                  </a:rPr>
-                  <a:t>  Actual max coverage=6,305; sort-and-chop max=7.</a:t>
-                </a:r>
-              </a:p>
-              <a:p>
-                <a:pPr>
-                  <a:lnSpc>
-                    <a:spcPct val="150000"/>
-                  </a:lnSpc>
-                  <a:buChar char="•"/>
-                </a:pPr>
-                <a:r>
-                  <a:rPr sz="1000" b="0" i="0" baseline="0" dirty="0">
-                    <a:latin typeface="Calibri"/>
-                  </a:rPr>
-                  <a:t>  </a:t>
-                </a:r>
-                <a14:m>
-                  <m:oMath xmlns:m="http://schemas.openxmlformats.org/officeDocument/2006/math">
-                    <m:r>
-                      <a:rPr lang="en-US" sz="1000" b="0" i="0" baseline="0" dirty="0" smtClean="0">
-                        <a:latin typeface="Cambria Math" panose="02040503050406030204" pitchFamily="18" charset="0"/>
-                      </a:rPr>
-                      <m:t>86%</m:t>
-                    </m:r>
-                  </m:oMath>
-                </a14:m>
-                <a:r>
-                  <a:rPr sz="1000" b="0" i="0" baseline="0" dirty="0">
-                    <a:latin typeface="Calibri"/>
-                  </a:rPr>
-                  <a:t> of grid points have </a:t>
-                </a:r>
-                <a14:m>
-                  <m:oMath xmlns:m="http://schemas.openxmlformats.org/officeDocument/2006/math">
-                    <m:r>
-                      <a:rPr lang="en-US" sz="1000" b="0" i="0" baseline="0" dirty="0" smtClean="0">
-                        <a:latin typeface="Cambria Math" panose="02040503050406030204" pitchFamily="18" charset="0"/>
-                      </a:rPr>
-                      <m:t>&gt;1</m:t>
-                    </m:r>
-                  </m:oMath>
-                </a14:m>
-                <a:r>
-                  <a:rPr sz="1000" b="0" i="0" baseline="0" dirty="0">
-                    <a:latin typeface="Calibri"/>
-                  </a:rPr>
-                  <a:t> team covering.</a:t>
-                </a:r>
-              </a:p>
-              <a:p>
-                <a:pPr>
-                  <a:lnSpc>
-                    <a:spcPct val="150000"/>
-                  </a:lnSpc>
-                  <a:buChar char="•"/>
-                </a:pPr>
-                <a:r>
-                  <a:rPr sz="1000" b="0" i="0" baseline="0" dirty="0">
-                    <a:latin typeface="Calibri"/>
-                  </a:rPr>
-                  <a:t>  Roster span: mean=2.98 z, median=2.87 z (6,492 team-seasons).</a:t>
-                </a:r>
-              </a:p>
-              <a:p>
-                <a:pPr>
-                  <a:lnSpc>
-                    <a:spcPct val="150000"/>
-                  </a:lnSpc>
-                  <a:buChar char="•"/>
-                </a:pPr>
-                <a:r>
-                  <a:rPr sz="1000" b="0" i="0" baseline="0" dirty="0">
-                    <a:latin typeface="Calibri"/>
-                  </a:rPr>
-                  <a:t>  Pairs with Phase B </a:t>
-                </a:r>
-                <a14:m>
-                  <m:oMath xmlns:m="http://schemas.openxmlformats.org/officeDocument/2006/math">
-                    <m:r>
-                      <a:rPr lang="en-US" sz="1000" b="0" i="0" baseline="0" dirty="0" smtClean="0">
-                        <a:latin typeface="Cambria Math" panose="02040503050406030204" pitchFamily="18" charset="0"/>
-                      </a:rPr>
-                      <m:t>𝜌</m:t>
-                    </m:r>
-                  </m:oMath>
-                </a14:m>
-                <a:r>
-                  <a:rPr sz="1000" b="0" i="0" baseline="0" dirty="0">
-                    <a:latin typeface="Calibri"/>
-                  </a:rPr>
-                  <a:t> slide — sim </a:t>
-                </a:r>
-                <a14:m>
-                  <m:oMath xmlns:m="http://schemas.openxmlformats.org/officeDocument/2006/math">
-                    <m:r>
-                      <a:rPr lang="en-US" sz="1000" b="0" i="0" baseline="0" dirty="0" smtClean="0">
-                        <a:latin typeface="Cambria Math" panose="02040503050406030204" pitchFamily="18" charset="0"/>
-                      </a:rPr>
-                      <m:t>𝜌</m:t>
-                    </m:r>
-                  </m:oMath>
-                </a14:m>
-                <a:r>
-                  <a:rPr sz="1000" b="0" i="0" baseline="0" dirty="0">
-                    <a:latin typeface="Calibri"/>
-                  </a:rPr>
-                  <a:t> dials overlap between these curves.</a:t>
-                </a:r>
-              </a:p>
-            </p:txBody>
-          </p:sp>
-        </mc:Choice>
-        <mc:Fallback xmlns="">
-          <p:sp>
-            <p:nvSpPr>
-              <p:cNvPr id="5" name="TextBox 4"/>
-              <p:cNvSpPr txBox="1">
-                <a:spLocks noRot="1" noChangeAspect="1" noMove="1" noResize="1" noEditPoints="1" noAdjustHandles="1" noChangeArrowheads="1" noChangeShapeType="1" noTextEdit="1"/>
-              </p:cNvSpPr>
-              <p:nvPr/>
-            </p:nvSpPr>
-            <p:spPr>
-              <a:xfrm>
-                <a:off x="185744" y="1280160"/>
-                <a:ext cx="4221664" cy="1697516"/>
-              </a:xfrm>
-              <a:prstGeom prst="rect">
-                <a:avLst/>
-              </a:prstGeom>
-              <a:blipFill>
-                <a:blip r:embed="rId4"/>
-                <a:stretch>
-                  <a:fillRect b="-1481"/>
-                </a:stretch>
-              </a:blipFill>
-            </p:spPr>
-            <p:txBody>
-              <a:bodyPr/>
-              <a:lstStyle/>
-              <a:p>
-                <a:r>
-                  <a:rPr lang="en-US">
-                    <a:noFill/>
-                  </a:rPr>
-                  <a:t> </a:t>
-                </a:r>
-              </a:p>
-            </p:txBody>
-          </p:sp>
-        </mc:Fallback>
-      </mc:AlternateContent>
-      <mc:AlternateContent xmlns:mc="http://schemas.openxmlformats.org/markup-compatibility/2006" xmlns:a14="http://schemas.microsoft.com/office/drawing/2010/main">
-        <mc:Choice Requires="a14">
-          <p:sp>
-            <p:nvSpPr>
-              <p:cNvPr id="6" name="TextBox 5"/>
-              <p:cNvSpPr txBox="1"/>
-              <p:nvPr/>
-            </p:nvSpPr>
-            <p:spPr>
-              <a:xfrm>
-                <a:off x="384048" y="6494005"/>
-                <a:ext cx="11423599" cy="261610"/>
-              </a:xfrm>
-              <a:prstGeom prst="rect">
-                <a:avLst/>
-              </a:prstGeom>
-              <a:noFill/>
-            </p:spPr>
-            <p:txBody>
-              <a:bodyPr wrap="square">
-                <a:spAutoFit/>
-              </a:bodyPr>
-              <a:lstStyle/>
-              <a:p>
-                <a:pPr algn="l"/>
-                <a:r>
-                  <a:rPr sz="1100" b="1" i="0" baseline="0" dirty="0">
-                    <a:latin typeface="Calibri"/>
-                  </a:rPr>
-                  <a:t>Claim (PD17): Real NCAA rosters leave massively overlapping team talent windows — the empirical target </a:t>
-                </a:r>
-                <a14:m>
-                  <m:oMath xmlns:m="http://schemas.openxmlformats.org/officeDocument/2006/math">
-                    <m:r>
-                      <a:rPr lang="en-US" sz="1100" b="1" i="0" baseline="0" dirty="0" smtClean="0">
-                        <a:latin typeface="Cambria Math" panose="02040503050406030204" pitchFamily="18" charset="0"/>
-                      </a:rPr>
-                      <m:t>𝜌</m:t>
-                    </m:r>
-                  </m:oMath>
-                </a14:m>
-                <a:r>
-                  <a:rPr sz="1100" b="1" i="0" baseline="0" dirty="0">
-                    <a:latin typeface="Calibri"/>
-                  </a:rPr>
-                  <a:t> was meant to match in sim (530 CELL 8 / 538 Plot A).</a:t>
-                </a:r>
-              </a:p>
-            </p:txBody>
-          </p:sp>
-        </mc:Choice>
-        <mc:Fallback xmlns="">
-          <p:sp>
-            <p:nvSpPr>
-              <p:cNvPr id="6" name="TextBox 5"/>
-              <p:cNvSpPr txBox="1">
-                <a:spLocks noRot="1" noChangeAspect="1" noMove="1" noResize="1" noEditPoints="1" noAdjustHandles="1" noChangeArrowheads="1" noChangeShapeType="1" noTextEdit="1"/>
-              </p:cNvSpPr>
-              <p:nvPr/>
-            </p:nvSpPr>
-            <p:spPr>
-              <a:xfrm>
-                <a:off x="384048" y="6494005"/>
-                <a:ext cx="11423599" cy="261610"/>
-              </a:xfrm>
-              <a:prstGeom prst="rect">
-                <a:avLst/>
-              </a:prstGeom>
-              <a:blipFill>
-                <a:blip r:embed="rId5"/>
-                <a:stretch>
-                  <a:fillRect b="-14286"/>
-                </a:stretch>
-              </a:blipFill>
-            </p:spPr>
-            <p:txBody>
-              <a:bodyPr/>
-              <a:lstStyle/>
-              <a:p>
-                <a:r>
-                  <a:rPr lang="en-US">
-                    <a:noFill/>
-                  </a:rPr>
-                  <a:t> </a:t>
-                </a:r>
-              </a:p>
-            </p:txBody>
-          </p:sp>
-        </mc:Fallback>
-      </mc:AlternateContent>
+      <p:pic>
+        <p:nvPicPr>
+          <p:cNvPr id="4" name="Picture 3" descr="image.png"/>
+          <p:cNvPicPr>
+            <a:picLocks noChangeAspect="1"/>
+          </p:cNvPicPr>
+          <p:nvPr/>
+        </p:nvPicPr>
+        <p:blipFill>
+          <a:blip r:embed="rId6"/>
+          <a:stretch>
+            <a:fillRect/>
+          </a:stretch>
+        </p:blipFill>
+        <p:spPr>
+          <a:xfrm>
+            <a:off x="4834069" y="1033272"/>
+            <a:ext cx="6519484" cy="4983480"/>
+          </a:xfrm>
+          <a:prstGeom prst="rect">
+            <a:avLst/>
+          </a:prstGeom>
+        </p:spPr>
+      </p:pic>
+      <p:sp>
+        <p:nvSpPr>
+          <p:cNvPr id="5" name="TextBox 4"/>
+          <p:cNvSpPr txBox="1"/>
+          <p:nvPr/>
+        </p:nvSpPr>
+        <p:spPr>
+          <a:xfrm>
+            <a:off x="384048" y="3849624"/>
+            <a:ext cx="3794760" cy="2148840"/>
+          </a:xfrm>
+          <a:prstGeom prst="rect">
+            <a:avLst/>
+          </a:prstGeom>
+          <a:noFill/>
+        </p:spPr>
+        <p:txBody>
+          <a:bodyPr wrap="square">
+            <a:spAutoFit/>
+          </a:bodyPr>
+          <a:lstStyle/>
+          <a:p>
+            <a:pPr>
+              <a:buChar char="•"/>
+              <a:lnSpc>
+                <a:spcPct val="150000"/>
+              </a:lnSpc>
+              <a:spcBef>
+                <a:spcPts val="0"/>
+              </a:spcBef>
+              <a:spcAft>
+                <a:spcPts val="0"/>
+              </a:spcAft>
+            </a:pPr>
+            <a:r>
+              <a:rPr sz="1000" b="0" i="0" baseline="0">
+                <a:latin typeface="Calibri"/>
+              </a:rPr>
+              <a:t>  Each team-season: talent window [\min \hat{A}_{i}, \max \hat{A}_{i}] on PPM z.</a:t>
+            </a:r>
+          </a:p>
+          <a:p>
+            <a:pPr>
+              <a:buChar char="•"/>
+              <a:lnSpc>
+                <a:spcPct val="150000"/>
+              </a:lnSpc>
+              <a:spcBef>
+                <a:spcPts val="0"/>
+              </a:spcBef>
+              <a:spcAft>
+                <a:spcPts val="0"/>
+              </a:spcAft>
+            </a:pPr>
+            <a:r>
+              <a:rPr sz="1000" b="0" i="0" baseline="0">
+                <a:latin typeface="Calibri"/>
+              </a:rPr>
+              <a:t>  Coverage = how many windows cover a point on the spectrum (530 CELL 8).</a:t>
+            </a:r>
+          </a:p>
+          <a:p>
+            <a:pPr>
+              <a:buChar char="•"/>
+              <a:lnSpc>
+                <a:spcPct val="150000"/>
+              </a:lnSpc>
+              <a:spcBef>
+                <a:spcPts val="0"/>
+              </a:spcBef>
+              <a:spcAft>
+                <a:spcPts val="0"/>
+              </a:spcAft>
+            </a:pPr>
+            <a:r>
+              <a:rPr sz="1000" b="0" i="0" baseline="0">
+                <a:latin typeface="Calibri"/>
+              </a:rPr>
+              <a:t>  H_{sort} = 1 - \sum_i(\hat{A}_i - \hat{\mu}_{g(i)})^2 / \sum_i(\hat{A}_i - \bar{A})^2 — realized sorting on a fixed partition.</a:t>
+            </a:r>
+          </a:p>
+          <a:p>
+            <a:pPr>
+              <a:buChar char="•"/>
+              <a:lnSpc>
+                <a:spcPct val="150000"/>
+              </a:lnSpc>
+              <a:spcBef>
+                <a:spcPts val="0"/>
+              </a:spcBef>
+              <a:spcAft>
+                <a:spcPts val="0"/>
+              </a:spcAft>
+            </a:pPr>
+            <a:r>
+              <a:rPr sz="1000" b="0" i="0" baseline="0">
+                <a:latin typeface="Calibri"/>
+              </a:rPr>
+              <a:t>  Empirical partition: H_{sort} = 0.105 (0 = none, 1 = full team sorting).</a:t>
+            </a:r>
+          </a:p>
+          <a:p>
+            <a:pPr>
+              <a:buChar char="•"/>
+              <a:lnSpc>
+                <a:spcPct val="150000"/>
+              </a:lnSpc>
+              <a:spcBef>
+                <a:spcPts val="0"/>
+              </a:spcBef>
+              <a:spcAft>
+                <a:spcPts val="0"/>
+              </a:spcAft>
+            </a:pPr>
+            <a:r>
+              <a:rPr sz="1000" b="0" i="0" baseline="0">
+                <a:latin typeface="Calibri"/>
+              </a:rPr>
+              <a:t>  Max coverage=6,305; sort-and-chop max=7.</a:t>
+            </a:r>
+          </a:p>
+          <a:p>
+            <a:pPr>
+              <a:buChar char="•"/>
+              <a:lnSpc>
+                <a:spcPct val="150000"/>
+              </a:lnSpc>
+              <a:spcBef>
+                <a:spcPts val="0"/>
+              </a:spcBef>
+              <a:spcAft>
+                <a:spcPts val="0"/>
+              </a:spcAft>
+            </a:pPr>
+            <a:r>
+              <a:rPr sz="1000" b="0" i="0" baseline="0">
+                <a:latin typeface="Calibri"/>
+              </a:rPr>
+              <a:t>  Roster span: mean=2.98 z (6,492 team-seasons).</a:t>
+            </a:r>
+          </a:p>
+          <a:p>
+            <a:pPr>
+              <a:buChar char="•"/>
+              <a:lnSpc>
+                <a:spcPct val="150000"/>
+              </a:lnSpc>
+              <a:spcBef>
+                <a:spcPts val="0"/>
+              </a:spcBef>
+              <a:spcAft>
+                <a:spcPts val="0"/>
+              </a:spcAft>
+            </a:pPr>
+            <a:r>
+              <a:rPr sz="1000" b="0" i="0" baseline="0">
+                <a:latin typeface="Calibri"/>
+              </a:rPr>
+              <a:t>  VECTOR lock: H_{sort} is realized sorting — not the generative homophily knob \rho.</a:t>
+            </a:r>
+          </a:p>
+        </p:txBody>
+      </p:sp>
+      <p:sp>
+        <p:nvSpPr>
+          <p:cNvPr id="6" name="TextBox 5"/>
+          <p:cNvSpPr txBox="1"/>
+          <p:nvPr/>
+        </p:nvSpPr>
+        <p:spPr>
+          <a:xfrm>
+            <a:off x="384048" y="6053328"/>
+            <a:ext cx="11423599" cy="420624"/>
+          </a:xfrm>
+          <a:prstGeom prst="rect">
+            <a:avLst/>
+          </a:prstGeom>
+          <a:noFill/>
+        </p:spPr>
+        <p:txBody>
+          <a:bodyPr wrap="square">
+            <a:spAutoFit/>
+          </a:bodyPr>
+          <a:lstStyle/>
+          <a:p>
+            <a:pPr algn="l"/>
+            <a:r>
+              <a:rPr sz="1100" b="1" i="0" baseline="0">
+                <a:latin typeface="Calibri"/>
+              </a:rPr>
+              <a:t>Claim (PD17): Real NCAA rosters leave massively overlapping team talent windows — compare H_{sort} on this partition to Grandchild sim (slide 4).</a:t>
+            </a:r>
+          </a:p>
+        </p:txBody>
+      </p:sp>
     </p:spTree>
   </p:cSld>
   <p:clrMapOvr>
@@ -8169,1170 +7803,287 @@
           <a:chExt cx="0" cy="0"/>
         </a:xfrm>
       </p:grpSpPr>
-      <mc:AlternateContent xmlns:mc="http://schemas.openxmlformats.org/markup-compatibility/2006" xmlns:a14="http://schemas.microsoft.com/office/drawing/2010/main">
-        <mc:Choice Requires="a14">
-          <p:sp>
-            <p:nvSpPr>
-              <p:cNvPr id="2" name="TextBox 1"/>
-              <p:cNvSpPr txBox="1"/>
-              <p:nvPr/>
-            </p:nvSpPr>
-            <p:spPr>
-              <a:xfrm>
-                <a:off x="384048" y="219456"/>
-                <a:ext cx="10208757" cy="677108"/>
-              </a:xfrm>
-              <a:prstGeom prst="rect">
-                <a:avLst/>
-              </a:prstGeom>
-              <a:noFill/>
-            </p:spPr>
-            <p:txBody>
-              <a:bodyPr wrap="none">
-                <a:spAutoFit/>
-              </a:bodyPr>
-              <a:lstStyle/>
-              <a:p>
-                <a:r>
-                  <a:rPr sz="2000" b="1" i="0" baseline="0" dirty="0">
-                    <a:latin typeface="Calibri"/>
-                  </a:rPr>
-                  <a:t>PD17 — Empirical team </a:t>
-                </a:r>
-                <a14:m>
-                  <m:oMath xmlns:m="http://schemas.openxmlformats.org/officeDocument/2006/math">
-                    <m:sSub>
-                      <m:sSubPr>
-                        <m:ctrlPr>
-                          <a:rPr lang="en-US" sz="2000" b="1" i="1" baseline="0" dirty="0" smtClean="0">
-                            <a:latin typeface="Cambria Math" panose="02040503050406030204" pitchFamily="18" charset="0"/>
-                          </a:rPr>
-                        </m:ctrlPr>
-                      </m:sSubPr>
-                      <m:e>
-                        <m:r>
-                          <a:rPr lang="en-US" sz="2000" b="1" i="0" baseline="0" dirty="0">
-                            <a:latin typeface="Cambria Math" panose="02040503050406030204" pitchFamily="18" charset="0"/>
-                          </a:rPr>
-                          <m:t>𝐿</m:t>
-                        </m:r>
-                      </m:e>
-                      <m:sub>
-                        <m:r>
-                          <a:rPr lang="en-US" sz="2000" b="1" i="0" baseline="0" dirty="0">
-                            <a:latin typeface="Cambria Math" panose="02040503050406030204" pitchFamily="18" charset="0"/>
-                          </a:rPr>
-                          <m:t>𝐶</m:t>
-                        </m:r>
-                      </m:sub>
-                    </m:sSub>
-                  </m:oMath>
-                </a14:m>
-                <a:r>
-                  <a:rPr sz="2000" b="1" i="0" baseline="0" dirty="0">
-                    <a:latin typeface="Calibri"/>
-                  </a:rPr>
-                  <a:t> distribution</a:t>
-                </a:r>
-                <a:endParaRPr lang="en-US" sz="2000" b="1" i="0" baseline="0" dirty="0">
-                  <a:latin typeface="Calibri"/>
-                </a:endParaRPr>
-              </a:p>
-              <a:p>
-                <a:r>
-                  <a:rPr lang="en-US" i="1" dirty="0">
-                    <a:latin typeface="Avenir Next Medium" panose="020B0503020202020204" pitchFamily="34" charset="0"/>
-                  </a:rPr>
-                  <a:t>Given overlapping talent windows (prior slide), team </a:t>
-                </a:r>
-                <a14:m>
-                  <m:oMath xmlns:m="http://schemas.openxmlformats.org/officeDocument/2006/math">
-                    <m:sSub>
-                      <m:sSubPr>
-                        <m:ctrlPr>
-                          <a:rPr lang="en-US" i="1" dirty="0" smtClean="0">
-                            <a:latin typeface="Cambria Math" panose="02040503050406030204" pitchFamily="18" charset="0"/>
-                          </a:rPr>
-                        </m:ctrlPr>
-                      </m:sSubPr>
-                      <m:e>
-                        <m:r>
-                          <a:rPr lang="en-US" b="0" i="1" dirty="0">
-                            <a:latin typeface="Cambria Math" panose="02040503050406030204" pitchFamily="18" charset="0"/>
-                          </a:rPr>
-                          <m:t>𝐿</m:t>
-                        </m:r>
-                      </m:e>
-                      <m:sub>
-                        <m:r>
-                          <a:rPr lang="en-US" b="0" i="1" dirty="0">
-                            <a:latin typeface="Cambria Math" panose="02040503050406030204" pitchFamily="18" charset="0"/>
-                          </a:rPr>
-                          <m:t>𝐶</m:t>
-                        </m:r>
-                      </m:sub>
-                    </m:sSub>
-                  </m:oMath>
-                </a14:m>
-                <a:r>
-                  <a:rPr lang="en-US" i="1" dirty="0">
-                    <a:latin typeface="Avenir Next Medium" panose="020B0503020202020204" pitchFamily="34" charset="0"/>
-                  </a:rPr>
-                  <a:t> summarizes peer viability on each roster.</a:t>
-                </a:r>
-                <a:endParaRPr sz="2000" i="1" baseline="0" dirty="0">
-                  <a:latin typeface="Avenir Next Medium" panose="020B0503020202020204" pitchFamily="34" charset="0"/>
-                </a:endParaRPr>
-              </a:p>
-            </p:txBody>
-          </p:sp>
-        </mc:Choice>
-        <mc:Fallback xmlns="">
-          <p:sp>
-            <p:nvSpPr>
-              <p:cNvPr id="2" name="TextBox 1"/>
-              <p:cNvSpPr txBox="1">
-                <a:spLocks noRot="1" noChangeAspect="1" noMove="1" noResize="1" noEditPoints="1" noAdjustHandles="1" noChangeArrowheads="1" noChangeShapeType="1" noTextEdit="1"/>
-              </p:cNvSpPr>
-              <p:nvPr/>
-            </p:nvSpPr>
-            <p:spPr>
-              <a:xfrm>
-                <a:off x="384048" y="219456"/>
-                <a:ext cx="10208757" cy="677108"/>
-              </a:xfrm>
-              <a:prstGeom prst="rect">
-                <a:avLst/>
-              </a:prstGeom>
-              <a:blipFill>
-                <a:blip r:embed="rId2"/>
-                <a:stretch>
-                  <a:fillRect l="-621" t="-5556" r="-124" b="-14815"/>
-                </a:stretch>
-              </a:blipFill>
-            </p:spPr>
-            <p:txBody>
-              <a:bodyPr/>
-              <a:lstStyle/>
-              <a:p>
-                <a:r>
-                  <a:rPr lang="en-US">
-                    <a:noFill/>
-                  </a:rPr>
-                  <a:t> </a:t>
-                </a:r>
-              </a:p>
-            </p:txBody>
-          </p:sp>
-        </mc:Fallback>
-      </mc:AlternateContent>
-      <mc:AlternateContent xmlns:mc="http://schemas.openxmlformats.org/markup-compatibility/2006" xmlns:a14="http://schemas.microsoft.com/office/drawing/2010/main">
-        <mc:Choice Requires="a14">
-          <p:sp>
-            <p:nvSpPr>
-              <p:cNvPr id="3" name="TextBox 2"/>
-              <p:cNvSpPr txBox="1"/>
-              <p:nvPr/>
-            </p:nvSpPr>
-            <p:spPr>
-              <a:xfrm>
-                <a:off x="384048" y="1158719"/>
-                <a:ext cx="7688708" cy="270139"/>
-              </a:xfrm>
-              <a:prstGeom prst="rect">
-                <a:avLst/>
-              </a:prstGeom>
-              <a:noFill/>
-            </p:spPr>
-            <p:txBody>
-              <a:bodyPr wrap="none">
-                <a:spAutoFit/>
-              </a:bodyPr>
-              <a:lstStyle/>
-              <a:p>
-                <a:r>
-                  <a:rPr sz="1000" b="0" i="0" baseline="0" dirty="0">
-                    <a:latin typeface="Calibri"/>
-                  </a:rPr>
-                  <a:t>MBB 2011-2021 · team smooth </a:t>
-                </a:r>
-                <a14:m>
-                  <m:oMath xmlns:m="http://schemas.openxmlformats.org/officeDocument/2006/math">
-                    <m:sSub>
-                      <m:sSubPr>
-                        <m:ctrlPr>
-                          <a:rPr lang="en-US" sz="1000" b="0" i="1" baseline="0" dirty="0" smtClean="0">
-                            <a:latin typeface="Cambria Math" panose="02040503050406030204" pitchFamily="18" charset="0"/>
-                          </a:rPr>
-                        </m:ctrlPr>
-                      </m:sSubPr>
-                      <m:e>
-                        <m:r>
-                          <a:rPr lang="en-US" sz="1000" b="0" i="0" baseline="0" dirty="0">
-                            <a:latin typeface="Cambria Math" panose="02040503050406030204" pitchFamily="18" charset="0"/>
-                          </a:rPr>
-                          <m:t>𝐿</m:t>
-                        </m:r>
-                      </m:e>
-                      <m:sub>
-                        <m:r>
-                          <a:rPr lang="en-US" sz="1000" b="0" i="0" baseline="0" dirty="0">
-                            <a:latin typeface="Cambria Math" panose="02040503050406030204" pitchFamily="18" charset="0"/>
-                          </a:rPr>
-                          <m:t>𝐶</m:t>
-                        </m:r>
-                      </m:sub>
-                    </m:sSub>
-                  </m:oMath>
-                </a14:m>
-                <a:r>
-                  <a:rPr sz="1000" b="0" i="0" baseline="0" dirty="0">
-                    <a:latin typeface="Calibri"/>
-                  </a:rPr>
-                  <a:t> · PPM z within season · min 20 min · </a:t>
-                </a:r>
-                <a14:m>
-                  <m:oMath xmlns:m="http://schemas.openxmlformats.org/officeDocument/2006/math">
-                    <m:r>
-                      <a:rPr lang="en-US" sz="1000" b="0" i="0" baseline="0" dirty="0" smtClean="0">
-                        <a:latin typeface="Cambria Math" panose="02040503050406030204" pitchFamily="18" charset="0"/>
-                      </a:rPr>
-                      <m:t>𝜃</m:t>
-                    </m:r>
-                    <m:r>
-                      <a:rPr lang="en-US" sz="1000" b="0" i="0" baseline="0" dirty="0" smtClean="0">
-                        <a:latin typeface="Cambria Math" panose="02040503050406030204" pitchFamily="18" charset="0"/>
-                      </a:rPr>
-                      <m:t>=</m:t>
-                    </m:r>
-                    <m:sSubSup>
-                      <m:sSubSupPr>
-                        <m:ctrlPr>
-                          <a:rPr lang="en-US" sz="1000" b="0" i="1" baseline="0" dirty="0">
-                            <a:latin typeface="Cambria Math" panose="02040503050406030204" pitchFamily="18" charset="0"/>
-                          </a:rPr>
-                        </m:ctrlPr>
-                      </m:sSubSupPr>
-                      <m:e>
-                        <m:r>
-                          <a:rPr lang="en-US" sz="1000" b="0" i="0" baseline="0" dirty="0">
-                            <a:latin typeface="Cambria Math" panose="02040503050406030204" pitchFamily="18" charset="0"/>
-                          </a:rPr>
-                          <m:t>𝐹</m:t>
-                        </m:r>
-                      </m:e>
-                      <m:sub>
-                        <m:acc>
-                          <m:accPr>
-                            <m:chr m:val="ˆ"/>
-                            <m:ctrlPr>
-                              <a:rPr lang="en-US" sz="1000" b="0" i="1" baseline="0" dirty="0">
-                                <a:latin typeface="Cambria Math" panose="02040503050406030204" pitchFamily="18" charset="0"/>
-                              </a:rPr>
-                            </m:ctrlPr>
-                          </m:accPr>
-                          <m:e>
-                            <m:r>
-                              <a:rPr lang="en-US" sz="1000" b="0" i="0" baseline="0" dirty="0">
-                                <a:latin typeface="Cambria Math" panose="02040503050406030204" pitchFamily="18" charset="0"/>
-                              </a:rPr>
-                              <m:t>𝐴</m:t>
-                            </m:r>
-                          </m:e>
-                        </m:acc>
-                      </m:sub>
-                      <m:sup>
-                        <m:r>
-                          <a:rPr lang="en-US" sz="1000" b="0" i="0" baseline="0" dirty="0">
-                            <a:latin typeface="Cambria Math" panose="02040503050406030204" pitchFamily="18" charset="0"/>
-                          </a:rPr>
-                          <m:t>−1</m:t>
-                        </m:r>
-                      </m:sup>
-                    </m:sSubSup>
-                    <m:d>
-                      <m:dPr>
-                        <m:ctrlPr>
-                          <a:rPr lang="en-US" sz="1000" b="0" i="1" baseline="0" dirty="0">
-                            <a:latin typeface="Cambria Math" panose="02040503050406030204" pitchFamily="18" charset="0"/>
-                          </a:rPr>
-                        </m:ctrlPr>
-                      </m:dPr>
-                      <m:e>
-                        <m:r>
-                          <a:rPr lang="en-US" sz="1000" b="0" i="0" baseline="0" dirty="0">
-                            <a:latin typeface="Cambria Math" panose="02040503050406030204" pitchFamily="18" charset="0"/>
-                          </a:rPr>
-                          <m:t>1−</m:t>
-                        </m:r>
-                        <m:r>
-                          <a:rPr lang="en-US" sz="1000" b="0" i="0" baseline="0" dirty="0">
-                            <a:latin typeface="Cambria Math" panose="02040503050406030204" pitchFamily="18" charset="0"/>
-                          </a:rPr>
-                          <m:t>𝐾</m:t>
-                        </m:r>
-                        <m:r>
-                          <a:rPr lang="en-US" sz="1000" b="0" i="0" baseline="0" dirty="0">
-                            <a:latin typeface="Cambria Math" panose="02040503050406030204" pitchFamily="18" charset="0"/>
-                          </a:rPr>
-                          <m:t>/</m:t>
-                        </m:r>
-                        <m:r>
-                          <a:rPr lang="en-US" sz="1000" b="0" i="0" baseline="0" dirty="0">
-                            <a:latin typeface="Cambria Math" panose="02040503050406030204" pitchFamily="18" charset="0"/>
-                          </a:rPr>
-                          <m:t>𝑁</m:t>
-                        </m:r>
-                      </m:e>
-                    </m:d>
-                    <m:r>
-                      <a:rPr lang="en-US" sz="1000" b="0" i="0" baseline="0" dirty="0">
-                        <a:latin typeface="Cambria Math" panose="02040503050406030204" pitchFamily="18" charset="0"/>
-                      </a:rPr>
-                      <m:t>=2.295</m:t>
-                    </m:r>
-                    <m:r>
-                      <a:rPr lang="en-US" sz="1000" b="0" i="0" baseline="0" dirty="0" smtClean="0">
-                        <a:latin typeface="Cambria Math" panose="02040503050406030204" pitchFamily="18" charset="0"/>
-                      </a:rPr>
-                      <m:t> </m:t>
-                    </m:r>
-                    <m:d>
-                      <m:dPr>
-                        <m:ctrlPr>
-                          <a:rPr lang="en-US" sz="1000" b="0" i="1" baseline="0" dirty="0">
-                            <a:latin typeface="Cambria Math" panose="02040503050406030204" pitchFamily="18" charset="0"/>
-                          </a:rPr>
-                        </m:ctrlPr>
-                      </m:dPr>
-                      <m:e>
-                        <m:r>
-                          <a:rPr lang="en-US" sz="1000" b="0" i="0" baseline="0" dirty="0">
-                            <a:latin typeface="Cambria Math" panose="02040503050406030204" pitchFamily="18" charset="0"/>
-                          </a:rPr>
-                          <m:t>𝐾</m:t>
-                        </m:r>
-                        <m:r>
-                          <a:rPr lang="en-US" sz="1000" b="0" i="0" baseline="0" dirty="0">
-                            <a:latin typeface="Cambria Math" panose="02040503050406030204" pitchFamily="18" charset="0"/>
-                          </a:rPr>
-                          <m:t>/</m:t>
-                        </m:r>
-                        <m:r>
-                          <a:rPr lang="en-US" sz="1000" b="0" i="0" baseline="0" dirty="0">
-                            <a:latin typeface="Cambria Math" panose="02040503050406030204" pitchFamily="18" charset="0"/>
-                          </a:rPr>
-                          <m:t>𝑁</m:t>
-                        </m:r>
-                        <m:r>
-                          <a:rPr lang="en-US" sz="1000" b="0" i="0" baseline="0" dirty="0">
-                            <a:latin typeface="Cambria Math" panose="02040503050406030204" pitchFamily="18" charset="0"/>
-                          </a:rPr>
-                          <m:t>=0.0182</m:t>
-                        </m:r>
-                      </m:e>
-                    </m:d>
-                  </m:oMath>
-                </a14:m>
-                <a:r>
-                  <a:rPr sz="1000" b="0" i="0" baseline="0" dirty="0">
-                    <a:latin typeface="Calibri"/>
-                  </a:rPr>
-                  <a:t>· </a:t>
-                </a:r>
-                <a14:m>
-                  <m:oMath xmlns:m="http://schemas.openxmlformats.org/officeDocument/2006/math">
-                    <m:r>
-                      <a:rPr lang="en-US" sz="1000" b="0" i="0" baseline="0" dirty="0" smtClean="0">
-                        <a:latin typeface="Cambria Math" panose="02040503050406030204" pitchFamily="18" charset="0"/>
-                      </a:rPr>
-                      <m:t>𝛾</m:t>
-                    </m:r>
-                    <m:r>
-                      <a:rPr lang="en-US" sz="1000" b="0" i="0" baseline="0" dirty="0" smtClean="0">
-                        <a:latin typeface="Cambria Math" panose="02040503050406030204" pitchFamily="18" charset="0"/>
-                      </a:rPr>
-                      <m:t>=0.5</m:t>
-                    </m:r>
-                  </m:oMath>
-                </a14:m>
-                <a:r>
-                  <a:rPr sz="1000" b="0" i="0" baseline="0" dirty="0">
-                    <a:latin typeface="Calibri"/>
-                  </a:rPr>
-                  <a:t> placeholder</a:t>
-                </a:r>
-              </a:p>
-            </p:txBody>
-          </p:sp>
-        </mc:Choice>
-        <mc:Fallback xmlns="">
-          <p:sp>
-            <p:nvSpPr>
-              <p:cNvPr id="3" name="TextBox 2"/>
-              <p:cNvSpPr txBox="1">
-                <a:spLocks noRot="1" noChangeAspect="1" noMove="1" noResize="1" noEditPoints="1" noAdjustHandles="1" noChangeArrowheads="1" noChangeShapeType="1" noTextEdit="1"/>
-              </p:cNvSpPr>
-              <p:nvPr/>
-            </p:nvSpPr>
-            <p:spPr>
-              <a:xfrm>
-                <a:off x="384048" y="1158719"/>
-                <a:ext cx="7688708" cy="270139"/>
-              </a:xfrm>
-              <a:prstGeom prst="rect">
-                <a:avLst/>
-              </a:prstGeom>
-              <a:blipFill>
-                <a:blip r:embed="rId3"/>
-                <a:stretch>
-                  <a:fillRect b="-9091"/>
-                </a:stretch>
-              </a:blipFill>
-            </p:spPr>
-            <p:txBody>
-              <a:bodyPr/>
-              <a:lstStyle/>
-              <a:p>
-                <a:r>
-                  <a:rPr lang="en-US">
-                    <a:noFill/>
-                  </a:rPr>
-                  <a:t> </a:t>
-                </a:r>
-              </a:p>
-            </p:txBody>
-          </p:sp>
-        </mc:Fallback>
-      </mc:AlternateContent>
-      <mc:AlternateContent xmlns:mc="http://schemas.openxmlformats.org/markup-compatibility/2006">
-        <mc:Choice xmlns:a14="http://schemas.microsoft.com/office/drawing/2010/main" Requires="a14">
-          <p:sp>
-            <p:nvSpPr>
-              <p:cNvPr id="4" name="TextBox 3"/>
-              <p:cNvSpPr txBox="1"/>
-              <p:nvPr/>
-            </p:nvSpPr>
-            <p:spPr>
-              <a:xfrm>
-                <a:off x="278989" y="1851773"/>
-                <a:ext cx="3949413" cy="1577227"/>
-              </a:xfrm>
-              <a:prstGeom prst="rect">
-                <a:avLst/>
-              </a:prstGeom>
-              <a:noFill/>
-            </p:spPr>
-            <p:txBody>
-              <a:bodyPr wrap="square">
-                <a:spAutoFit/>
-              </a:bodyPr>
-              <a:lstStyle/>
-              <a:p>
-                <a:pPr>
-                  <a:lnSpc>
-                    <a:spcPct val="150000"/>
-                  </a:lnSpc>
-                  <a:buChar char="•"/>
-                </a:pPr>
-                <a:r>
-                  <a:rPr sz="1000" b="0" i="0" baseline="0" dirty="0">
-                    <a:latin typeface="Calibri"/>
-                  </a:rPr>
-                  <a:t>  Team </a:t>
-                </a:r>
-                <a14:m>
-                  <m:oMath xmlns:m="http://schemas.openxmlformats.org/officeDocument/2006/math">
-                    <m:sSub>
-                      <m:sSubPr>
-                        <m:ctrlPr>
-                          <a:rPr lang="en-US" sz="1000" b="0" i="1" baseline="0" dirty="0" smtClean="0">
-                            <a:latin typeface="Cambria Math" panose="02040503050406030204" pitchFamily="18" charset="0"/>
-                          </a:rPr>
-                        </m:ctrlPr>
-                      </m:sSubPr>
-                      <m:e>
-                        <m:r>
-                          <a:rPr lang="en-US" sz="1000" b="0" i="0" baseline="0" dirty="0" smtClean="0">
-                            <a:latin typeface="Cambria Math" panose="02040503050406030204" pitchFamily="18" charset="0"/>
-                          </a:rPr>
-                          <m:t>𝐿</m:t>
-                        </m:r>
-                      </m:e>
-                      <m:sub>
-                        <m:r>
-                          <a:rPr lang="en-US" sz="1000" b="0" i="0" baseline="0" dirty="0" smtClean="0">
-                            <a:latin typeface="Cambria Math" panose="02040503050406030204" pitchFamily="18" charset="0"/>
-                          </a:rPr>
-                          <m:t>𝐶</m:t>
-                        </m:r>
-                      </m:sub>
-                    </m:sSub>
-                    <m:r>
-                      <a:rPr lang="en-US" sz="1000" b="0" i="0" baseline="0" dirty="0" smtClean="0">
-                        <a:latin typeface="Cambria Math" panose="02040503050406030204" pitchFamily="18" charset="0"/>
-                      </a:rPr>
-                      <m:t>=</m:t>
-                    </m:r>
-                    <m:r>
-                      <a:rPr lang="en-US" sz="1000" b="0" i="0" baseline="0" dirty="0" smtClean="0">
-                        <a:latin typeface="Cambria Math" panose="02040503050406030204" pitchFamily="18" charset="0"/>
-                      </a:rPr>
-                      <m:t>𝑚𝑒𝑎</m:t>
-                    </m:r>
-                    <m:sSub>
-                      <m:sSubPr>
-                        <m:ctrlPr>
-                          <a:rPr lang="en-US" sz="1000" b="0" i="1" baseline="0" dirty="0" smtClean="0">
-                            <a:latin typeface="Cambria Math" panose="02040503050406030204" pitchFamily="18" charset="0"/>
-                          </a:rPr>
-                        </m:ctrlPr>
-                      </m:sSubPr>
-                      <m:e>
-                        <m:r>
-                          <a:rPr lang="en-US" sz="1000" b="0" i="0" baseline="0" dirty="0" smtClean="0">
-                            <a:latin typeface="Cambria Math" panose="02040503050406030204" pitchFamily="18" charset="0"/>
-                          </a:rPr>
-                          <m:t>𝑛</m:t>
-                        </m:r>
-                      </m:e>
-                      <m:sub>
-                        <m:r>
-                          <a:rPr lang="en-US" sz="1000" b="0" i="0" baseline="0" dirty="0" smtClean="0">
-                            <a:latin typeface="Cambria Math" panose="02040503050406030204" pitchFamily="18" charset="0"/>
-                          </a:rPr>
-                          <m:t>𝑗</m:t>
-                        </m:r>
-                      </m:sub>
-                    </m:sSub>
-                    <m:r>
-                      <a:rPr lang="en-US" sz="1000" b="0" i="0" baseline="0" dirty="0" smtClean="0">
-                        <a:latin typeface="Cambria Math" panose="02040503050406030204" pitchFamily="18" charset="0"/>
-                      </a:rPr>
-                      <m:t> </m:t>
-                    </m:r>
-                    <m:r>
-                      <a:rPr lang="en-US" sz="1000" b="0" i="0" baseline="0" dirty="0" smtClean="0">
-                        <a:latin typeface="Cambria Math" panose="02040503050406030204" pitchFamily="18" charset="0"/>
-                      </a:rPr>
-                      <m:t>𝜎</m:t>
-                    </m:r>
-                    <m:d>
-                      <m:dPr>
-                        <m:ctrlPr>
-                          <a:rPr lang="en-US" sz="1000" b="0" i="1" baseline="0" dirty="0" smtClean="0">
-                            <a:latin typeface="Cambria Math" panose="02040503050406030204" pitchFamily="18" charset="0"/>
-                          </a:rPr>
-                        </m:ctrlPr>
-                      </m:dPr>
-                      <m:e>
-                        <m:r>
-                          <a:rPr lang="en-US" sz="1000" b="0" i="0" baseline="0" dirty="0" smtClean="0">
-                            <a:latin typeface="Cambria Math" panose="02040503050406030204" pitchFamily="18" charset="0"/>
-                          </a:rPr>
-                          <m:t>𝛾</m:t>
-                        </m:r>
-                        <m:d>
-                          <m:dPr>
-                            <m:ctrlPr>
-                              <a:rPr lang="en-US" sz="1000" b="0" i="1" baseline="0" dirty="0" smtClean="0">
-                                <a:latin typeface="Cambria Math" panose="02040503050406030204" pitchFamily="18" charset="0"/>
-                              </a:rPr>
-                            </m:ctrlPr>
-                          </m:dPr>
-                          <m:e>
-                            <m:sSub>
-                              <m:sSubPr>
-                                <m:ctrlPr>
-                                  <a:rPr lang="en-US" sz="1000" b="0" i="1" baseline="0" dirty="0" smtClean="0">
-                                    <a:latin typeface="Cambria Math" panose="02040503050406030204" pitchFamily="18" charset="0"/>
-                                  </a:rPr>
-                                </m:ctrlPr>
-                              </m:sSubPr>
-                              <m:e>
-                                <m:acc>
-                                  <m:accPr>
-                                    <m:chr m:val="ˆ"/>
-                                    <m:ctrlPr>
-                                      <a:rPr lang="en-US" sz="1000" b="0" i="1" baseline="0" dirty="0" smtClean="0">
-                                        <a:latin typeface="Cambria Math" panose="02040503050406030204" pitchFamily="18" charset="0"/>
-                                      </a:rPr>
-                                    </m:ctrlPr>
-                                  </m:accPr>
-                                  <m:e>
-                                    <m:r>
-                                      <a:rPr lang="en-US" sz="1000" b="0" i="0" baseline="0" dirty="0" smtClean="0">
-                                        <a:latin typeface="Cambria Math" panose="02040503050406030204" pitchFamily="18" charset="0"/>
-                                      </a:rPr>
-                                      <m:t>𝐴</m:t>
-                                    </m:r>
-                                  </m:e>
-                                </m:acc>
-                              </m:e>
-                              <m:sub>
-                                <m:r>
-                                  <a:rPr lang="en-US" sz="1000" b="0" i="0" baseline="0" dirty="0" smtClean="0">
-                                    <a:latin typeface="Cambria Math" panose="02040503050406030204" pitchFamily="18" charset="0"/>
-                                  </a:rPr>
-                                  <m:t>𝑗</m:t>
-                                </m:r>
-                              </m:sub>
-                            </m:sSub>
-                            <m:r>
-                              <a:rPr lang="en-US" sz="1000" b="0" i="0" baseline="0" dirty="0" smtClean="0">
-                                <a:latin typeface="Cambria Math" panose="02040503050406030204" pitchFamily="18" charset="0"/>
-                              </a:rPr>
-                              <m:t>−</m:t>
-                            </m:r>
-                            <m:r>
-                              <a:rPr lang="en-US" sz="1000" b="0" i="0" baseline="0" dirty="0" smtClean="0">
-                                <a:latin typeface="Cambria Math" panose="02040503050406030204" pitchFamily="18" charset="0"/>
-                              </a:rPr>
-                              <m:t>𝜃</m:t>
-                            </m:r>
-                          </m:e>
-                        </m:d>
-                      </m:e>
-                    </m:d>
-                  </m:oMath>
-                </a14:m>
-                <a:r>
-                  <a:rPr sz="1000" b="0" i="0" baseline="0" dirty="0">
-                    <a:latin typeface="Calibri"/>
-                  </a:rPr>
-                  <a:t> on each roster.</a:t>
-                </a:r>
-              </a:p>
-              <a:p>
-                <a:pPr>
-                  <a:lnSpc>
-                    <a:spcPct val="150000"/>
-                  </a:lnSpc>
-                  <a:buChar char="•"/>
-                </a:pPr>
-                <a:r>
-                  <a:rPr sz="1000" b="0" i="0" baseline="0" dirty="0">
-                    <a:latin typeface="Calibri"/>
-                  </a:rPr>
-                  <a:t>  Same PD16 team-smooth definition — one value per team-season.</a:t>
-                </a:r>
-              </a:p>
-              <a:p>
-                <a:pPr>
-                  <a:lnSpc>
-                    <a:spcPct val="150000"/>
-                  </a:lnSpc>
-                  <a:buChar char="•"/>
-                </a:pPr>
-                <a:r>
-                  <a:rPr sz="1000" b="0" i="0" baseline="0" dirty="0">
-                    <a:latin typeface="Calibri"/>
-                  </a:rPr>
-                  <a:t>  Not LOO; includes every roster member in the mean.</a:t>
-                </a:r>
-              </a:p>
-              <a:p>
-                <a:pPr>
-                  <a:lnSpc>
-                    <a:spcPct val="150000"/>
-                  </a:lnSpc>
-                  <a:buChar char="•"/>
-                </a:pPr>
-                <a:r>
-                  <a:rPr sz="1000" b="0" i="0" baseline="0" dirty="0">
-                    <a:latin typeface="Calibri"/>
-                  </a:rPr>
-                  <a:t>  </a:t>
-                </a:r>
-                <a14:m>
-                  <m:oMath xmlns:m="http://schemas.openxmlformats.org/officeDocument/2006/math">
-                    <m:r>
-                      <a:rPr lang="en-US" sz="1000" b="0" i="0" baseline="0" dirty="0" smtClean="0">
-                        <a:latin typeface="Cambria Math" panose="02040503050406030204" pitchFamily="18" charset="0"/>
-                      </a:rPr>
-                      <m:t>𝛾</m:t>
-                    </m:r>
-                    <m:r>
-                      <a:rPr lang="en-US" sz="1000" b="0" i="0" baseline="0" dirty="0" smtClean="0">
-                        <a:latin typeface="Cambria Math" panose="02040503050406030204" pitchFamily="18" charset="0"/>
-                      </a:rPr>
-                      <m:t>=0.5</m:t>
-                    </m:r>
-                  </m:oMath>
-                </a14:m>
-                <a:r>
-                  <a:rPr sz="1000" b="0" i="0" baseline="0" dirty="0">
-                    <a:latin typeface="Calibri"/>
-                  </a:rPr>
-                  <a:t> (539 placeholder until PD17 </a:t>
-                </a:r>
-                <a14:m>
-                  <m:oMath xmlns:m="http://schemas.openxmlformats.org/officeDocument/2006/math">
-                    <m:r>
-                      <a:rPr lang="en-US" sz="1000" b="0" i="0" baseline="0" dirty="0" smtClean="0">
-                        <a:latin typeface="Cambria Math" panose="02040503050406030204" pitchFamily="18" charset="0"/>
-                      </a:rPr>
-                      <m:t>𝛾</m:t>
-                    </m:r>
-                  </m:oMath>
-                </a14:m>
-                <a:r>
-                  <a:rPr sz="1000" b="0" i="0" baseline="0" dirty="0">
-                    <a:latin typeface="Calibri"/>
-                  </a:rPr>
-                  <a:t> / </a:t>
-                </a:r>
-                <a14:m>
-                  <m:oMath xmlns:m="http://schemas.openxmlformats.org/officeDocument/2006/math">
-                    <m:r>
-                      <a:rPr lang="en-US" sz="1000" b="0" i="0" baseline="0" dirty="0" smtClean="0">
-                        <a:latin typeface="Cambria Math" panose="02040503050406030204" pitchFamily="18" charset="0"/>
-                      </a:rPr>
-                      <m:t>𝜆</m:t>
-                    </m:r>
-                  </m:oMath>
-                </a14:m>
-                <a:r>
-                  <a:rPr sz="1000" b="0" i="0" baseline="0" dirty="0">
-                    <a:latin typeface="Calibri"/>
-                  </a:rPr>
-                  <a:t> calibration).</a:t>
-                </a:r>
-              </a:p>
-              <a:p>
-                <a:pPr>
-                  <a:lnSpc>
-                    <a:spcPct val="150000"/>
-                  </a:lnSpc>
-                  <a:buChar char="•"/>
-                </a:pPr>
-                <a:r>
-                  <a:rPr sz="1000" b="0" i="0" baseline="0" dirty="0">
-                    <a:latin typeface="Calibri"/>
-                  </a:rPr>
-                  <a:t>  This run: mean </a:t>
-                </a:r>
-                <a14:m>
-                  <m:oMath xmlns:m="http://schemas.openxmlformats.org/officeDocument/2006/math">
-                    <m:sSub>
-                      <m:sSubPr>
-                        <m:ctrlPr>
-                          <a:rPr lang="en-US" sz="1000" b="0" i="1" baseline="0" dirty="0" smtClean="0">
-                            <a:latin typeface="Cambria Math" panose="02040503050406030204" pitchFamily="18" charset="0"/>
-                          </a:rPr>
-                        </m:ctrlPr>
-                      </m:sSubPr>
-                      <m:e>
-                        <m:r>
-                          <a:rPr lang="en-US" sz="1000" b="0" i="0" baseline="0" dirty="0">
-                            <a:latin typeface="Cambria Math" panose="02040503050406030204" pitchFamily="18" charset="0"/>
-                          </a:rPr>
-                          <m:t>𝐿</m:t>
-                        </m:r>
-                      </m:e>
-                      <m:sub>
-                        <m:r>
-                          <a:rPr lang="en-US" sz="1000" b="0" i="0" baseline="0" dirty="0">
-                            <a:latin typeface="Cambria Math" panose="02040503050406030204" pitchFamily="18" charset="0"/>
-                          </a:rPr>
-                          <m:t>𝐶</m:t>
-                        </m:r>
-                      </m:sub>
-                    </m:sSub>
-                    <m:r>
-                      <a:rPr lang="en-US" sz="1000" b="0" i="0" baseline="0" dirty="0">
-                        <a:latin typeface="Cambria Math" panose="02040503050406030204" pitchFamily="18" charset="0"/>
-                      </a:rPr>
-                      <m:t>=0.254</m:t>
-                    </m:r>
-                  </m:oMath>
-                </a14:m>
-                <a:r>
-                  <a:rPr sz="1000" b="0" i="0" baseline="0" dirty="0">
-                    <a:latin typeface="Calibri"/>
-                  </a:rPr>
-                  <a:t>, sd</a:t>
-                </a:r>
-                <a14:m>
-                  <m:oMath xmlns:m="http://schemas.openxmlformats.org/officeDocument/2006/math">
-                    <m:r>
-                      <a:rPr lang="en-US" sz="1000" b="0" i="0" baseline="0" dirty="0" smtClean="0">
-                        <a:latin typeface="Cambria Math" panose="02040503050406030204" pitchFamily="18" charset="0"/>
-                      </a:rPr>
-                      <m:t> =0.039</m:t>
-                    </m:r>
-                  </m:oMath>
-                </a14:m>
-                <a:r>
-                  <a:rPr sz="1000" b="0" i="0" baseline="0" dirty="0">
-                    <a:latin typeface="Calibri"/>
-                  </a:rPr>
-                  <a:t> (</a:t>
-                </a:r>
-                <a14:m>
-                  <m:oMath xmlns:m="http://schemas.openxmlformats.org/officeDocument/2006/math">
-                    <m:r>
-                      <a:rPr lang="en-US" sz="1000" b="0" i="0" baseline="0" dirty="0" smtClean="0">
-                        <a:latin typeface="Cambria Math" panose="02040503050406030204" pitchFamily="18" charset="0"/>
-                      </a:rPr>
-                      <m:t>6,492</m:t>
-                    </m:r>
-                  </m:oMath>
-                </a14:m>
-                <a:r>
-                  <a:rPr sz="1000" b="0" i="0" baseline="0" dirty="0">
-                    <a:latin typeface="Calibri"/>
-                  </a:rPr>
-                  <a:t> team-seasons).</a:t>
-                </a:r>
-              </a:p>
-              <a:p>
-                <a:pPr>
-                  <a:lnSpc>
-                    <a:spcPct val="150000"/>
-                  </a:lnSpc>
-                  <a:buChar char="•"/>
-                </a:pPr>
-                <a:r>
-                  <a:rPr sz="1000" b="0" i="0" baseline="0" dirty="0">
-                    <a:latin typeface="Calibri"/>
-                  </a:rPr>
-                  <a:t>  </a:t>
-                </a:r>
-                <a14:m>
-                  <m:oMath xmlns:m="http://schemas.openxmlformats.org/officeDocument/2006/math">
-                    <m:r>
-                      <a:rPr lang="en-US" sz="1000" b="0" i="0" baseline="0" dirty="0" smtClean="0">
-                        <a:latin typeface="Cambria Math" panose="02040503050406030204" pitchFamily="18" charset="0"/>
-                      </a:rPr>
-                      <m:t>𝜃</m:t>
-                    </m:r>
-                  </m:oMath>
-                </a14:m>
-                <a:r>
-                  <a:rPr sz="1000" b="0" i="0" baseline="0" dirty="0">
-                    <a:latin typeface="Calibri"/>
-                  </a:rPr>
-                  <a:t> from draft rate: </a:t>
-                </a:r>
-                <a14:m>
-                  <m:oMath xmlns:m="http://schemas.openxmlformats.org/officeDocument/2006/math">
-                    <m:r>
-                      <a:rPr lang="en-US" sz="1000" b="0" i="0" baseline="0" dirty="0" smtClean="0">
-                        <a:latin typeface="Cambria Math" panose="02040503050406030204" pitchFamily="18" charset="0"/>
-                      </a:rPr>
-                      <m:t>𝐾</m:t>
-                    </m:r>
-                    <m:r>
-                      <a:rPr lang="en-US" sz="1000" b="0" i="0" baseline="0" dirty="0" smtClean="0">
-                        <a:latin typeface="Cambria Math" panose="02040503050406030204" pitchFamily="18" charset="0"/>
-                      </a:rPr>
-                      <m:t>/</m:t>
-                    </m:r>
-                    <m:r>
-                      <a:rPr lang="en-US" sz="1000" b="0" i="0" baseline="0" dirty="0" smtClean="0">
-                        <a:latin typeface="Cambria Math" panose="02040503050406030204" pitchFamily="18" charset="0"/>
-                      </a:rPr>
-                      <m:t>𝑁</m:t>
-                    </m:r>
-                    <m:r>
-                      <a:rPr lang="en-US" sz="1000" b="0" i="0" baseline="0" dirty="0" smtClean="0">
-                        <a:latin typeface="Cambria Math" panose="02040503050406030204" pitchFamily="18" charset="0"/>
-                      </a:rPr>
-                      <m:t>=0.0182⇒</m:t>
-                    </m:r>
-                    <m:r>
-                      <a:rPr lang="en-US" sz="1000" b="0" i="0" baseline="0" dirty="0" smtClean="0">
-                        <a:latin typeface="Cambria Math" panose="02040503050406030204" pitchFamily="18" charset="0"/>
-                      </a:rPr>
-                      <m:t>𝜃</m:t>
-                    </m:r>
-                    <m:r>
-                      <a:rPr lang="en-US" sz="1000" b="0" i="0" baseline="0" dirty="0" smtClean="0">
-                        <a:latin typeface="Cambria Math" panose="02040503050406030204" pitchFamily="18" charset="0"/>
-                      </a:rPr>
-                      <m:t>=2.295</m:t>
-                    </m:r>
-                  </m:oMath>
-                </a14:m>
-                <a:r>
-                  <a:rPr sz="1000" b="0" i="0" baseline="0" dirty="0">
-                    <a:latin typeface="Calibri"/>
-                  </a:rPr>
-                  <a:t> on </a:t>
-                </a:r>
-                <a14:m>
-                  <m:oMath xmlns:m="http://schemas.openxmlformats.org/officeDocument/2006/math">
-                    <m:sSub>
-                      <m:sSubPr>
-                        <m:ctrlPr>
-                          <a:rPr lang="en-US" sz="1000" b="0" i="1" baseline="0" dirty="0" smtClean="0">
-                            <a:latin typeface="Cambria Math" panose="02040503050406030204" pitchFamily="18" charset="0"/>
-                          </a:rPr>
-                        </m:ctrlPr>
-                      </m:sSubPr>
-                      <m:e>
-                        <m:acc>
-                          <m:accPr>
-                            <m:chr m:val="ˆ"/>
-                            <m:ctrlPr>
-                              <a:rPr lang="en-US" sz="1000" b="0" i="1" baseline="0" dirty="0">
-                                <a:latin typeface="Cambria Math" panose="02040503050406030204" pitchFamily="18" charset="0"/>
-                              </a:rPr>
-                            </m:ctrlPr>
-                          </m:accPr>
-                          <m:e>
-                            <m:r>
-                              <a:rPr lang="en-US" sz="1000" b="0" i="0" baseline="0" dirty="0">
-                                <a:latin typeface="Cambria Math" panose="02040503050406030204" pitchFamily="18" charset="0"/>
-                              </a:rPr>
-                              <m:t>𝐴</m:t>
-                            </m:r>
-                          </m:e>
-                        </m:acc>
-                      </m:e>
-                      <m:sub>
-                        <m:r>
-                          <a:rPr lang="en-US" sz="1000" b="0" i="0" baseline="0" dirty="0">
-                            <a:latin typeface="Cambria Math" panose="02040503050406030204" pitchFamily="18" charset="0"/>
-                          </a:rPr>
-                          <m:t>𝑖</m:t>
-                        </m:r>
-                      </m:sub>
-                    </m:sSub>
-                  </m:oMath>
-                </a14:m>
-                <a:r>
-                  <a:rPr sz="1000" b="0" i="0" baseline="0" dirty="0">
-                    <a:latin typeface="Calibri"/>
-                  </a:rPr>
-                  <a:t>.</a:t>
-                </a:r>
-              </a:p>
-            </p:txBody>
-          </p:sp>
-        </mc:Choice>
-        <mc:Fallback>
-          <p:sp>
-            <p:nvSpPr>
-              <p:cNvPr id="4" name="TextBox 3"/>
-              <p:cNvSpPr txBox="1">
-                <a:spLocks noRot="1" noChangeAspect="1" noMove="1" noResize="1" noEditPoints="1" noAdjustHandles="1" noChangeArrowheads="1" noChangeShapeType="1" noTextEdit="1"/>
-              </p:cNvSpPr>
-              <p:nvPr/>
-            </p:nvSpPr>
-            <p:spPr>
-              <a:xfrm>
-                <a:off x="278989" y="1851773"/>
-                <a:ext cx="3949413" cy="1577227"/>
-              </a:xfrm>
-              <a:prstGeom prst="rect">
-                <a:avLst/>
-              </a:prstGeom>
-              <a:blipFill>
-                <a:blip r:embed="rId4"/>
-                <a:stretch>
-                  <a:fillRect b="-794"/>
-                </a:stretch>
-              </a:blipFill>
-            </p:spPr>
-            <p:txBody>
-              <a:bodyPr/>
-              <a:lstStyle/>
-              <a:p>
-                <a:r>
-                  <a:rPr lang="en-US">
-                    <a:noFill/>
-                  </a:rPr>
-                  <a:t> </a:t>
-                </a:r>
-              </a:p>
-            </p:txBody>
-          </p:sp>
-        </mc:Fallback>
-      </mc:AlternateContent>
+      <p:sp>
+        <p:nvSpPr>
+          <p:cNvPr id="2" name="TextBox 1"/>
+          <p:cNvSpPr txBox="1"/>
+          <p:nvPr/>
+        </p:nvSpPr>
+        <p:spPr>
+          <a:xfrm>
+            <a:off x="384048" y="219456"/>
+            <a:ext cx="11423599" cy="418063680000"/>
+          </a:xfrm>
+          <a:prstGeom prst="rect">
+            <a:avLst/>
+          </a:prstGeom>
+          <a:noFill/>
+        </p:spPr>
+        <p:txBody>
+          <a:bodyPr wrap="none">
+            <a:spAutoFit/>
+          </a:bodyPr>
+          <a:lstStyle/>
+          <a:p>
+            <a:r>
+              <a:rPr sz="2000" b="1" i="0" baseline="0">
+                <a:latin typeface="Calibri"/>
+              </a:rPr>
+              <a:t>Grandchild sim — team \hat{A}_{i} interval overlap (\rho diagnostic)</a:t>
+            </a:r>
+          </a:p>
+        </p:txBody>
+      </p:sp>
+      <p:sp>
+        <p:nvSpPr>
+          <p:cNvPr id="3" name="TextBox 2"/>
+          <p:cNvSpPr txBox="1"/>
+          <p:nvPr/>
+        </p:nvSpPr>
+        <p:spPr>
+          <a:xfrm>
+            <a:off x="384048" y="713232"/>
+            <a:ext cx="11423599" cy="225754387200"/>
+          </a:xfrm>
+          <a:prstGeom prst="rect">
+            <a:avLst/>
+          </a:prstGeom>
+          <a:noFill/>
+        </p:spPr>
+        <p:txBody>
+          <a:bodyPr wrap="none">
+            <a:spAutoFit/>
+          </a:bodyPr>
+          <a:lstStyle/>
+          <a:p>
+            <a:r>
+              <a:rPr sz="1000" b="0" i="0" baseline="0">
+                <a:latin typeface="Calibri"/>
+              </a:rPr>
+              <a:t>2015 PPM z · Grandchild ASSIGN · \rho=0.5 · H_{sort}=0.157 · 402 teams</a:t>
+            </a:r>
+          </a:p>
+        </p:txBody>
+      </p:sp>
       <p:pic>
         <p:nvPicPr>
-          <p:cNvPr id="5" name="Picture 4"/>
+          <p:cNvPr id="4" name="Picture 3" descr="image.png"/>
           <p:cNvPicPr>
             <a:picLocks noChangeAspect="1"/>
           </p:cNvPicPr>
           <p:nvPr/>
         </p:nvPicPr>
         <p:blipFill>
-          <a:blip r:embed="rId5"/>
-          <a:srcRect/>
-          <a:stretch/>
+          <a:blip r:embed="rId7"/>
+          <a:stretch>
+            <a:fillRect/>
+          </a:stretch>
         </p:blipFill>
         <p:spPr>
           <a:xfrm>
-            <a:off x="3636625" y="1492383"/>
-            <a:ext cx="8164564" cy="4797258"/>
+            <a:off x="4877684" y="1033272"/>
+            <a:ext cx="6432254" cy="4983480"/>
           </a:xfrm>
           <a:prstGeom prst="rect">
             <a:avLst/>
           </a:prstGeom>
         </p:spPr>
       </p:pic>
-      <mc:AlternateContent xmlns:mc="http://schemas.openxmlformats.org/markup-compatibility/2006" xmlns:a14="http://schemas.microsoft.com/office/drawing/2010/main">
-        <mc:Choice Requires="a14">
-          <p:sp>
-            <p:nvSpPr>
-              <p:cNvPr id="6" name="TextBox 5"/>
-              <p:cNvSpPr txBox="1"/>
-              <p:nvPr/>
-            </p:nvSpPr>
-            <p:spPr>
-              <a:xfrm>
-                <a:off x="384048" y="6428472"/>
-                <a:ext cx="11423599" cy="261610"/>
-              </a:xfrm>
-              <a:prstGeom prst="rect">
-                <a:avLst/>
-              </a:prstGeom>
-              <a:noFill/>
-            </p:spPr>
-            <p:txBody>
-              <a:bodyPr wrap="square">
-                <a:spAutoFit/>
-              </a:bodyPr>
-              <a:lstStyle/>
-              <a:p>
-                <a:pPr algn="l"/>
-                <a:r>
-                  <a:rPr sz="1100" b="1" i="0" baseline="0" dirty="0">
-                    <a:latin typeface="Calibri"/>
-                  </a:rPr>
-                  <a:t>Claim (PD17): Real rosters carry a spread of team congestion </a:t>
-                </a:r>
-                <a14:m>
-                  <m:oMath xmlns:m="http://schemas.openxmlformats.org/officeDocument/2006/math">
-                    <m:sSub>
-                      <m:sSubPr>
-                        <m:ctrlPr>
-                          <a:rPr lang="en-US" sz="1100" b="1" i="1" baseline="0" dirty="0" smtClean="0">
-                            <a:latin typeface="Cambria Math" panose="02040503050406030204" pitchFamily="18" charset="0"/>
-                          </a:rPr>
-                        </m:ctrlPr>
-                      </m:sSubPr>
-                      <m:e>
-                        <m:r>
-                          <a:rPr lang="en-US" sz="1100" b="1" i="0" baseline="0" dirty="0">
-                            <a:latin typeface="Cambria Math" panose="02040503050406030204" pitchFamily="18" charset="0"/>
-                          </a:rPr>
-                          <m:t>𝐿</m:t>
-                        </m:r>
-                      </m:e>
-                      <m:sub>
-                        <m:r>
-                          <a:rPr lang="en-US" sz="1100" b="1" i="0" baseline="0" dirty="0">
-                            <a:latin typeface="Cambria Math" panose="02040503050406030204" pitchFamily="18" charset="0"/>
-                          </a:rPr>
-                          <m:t>𝐶</m:t>
-                        </m:r>
-                      </m:sub>
-                    </m:sSub>
-                  </m:oMath>
-                </a14:m>
-                <a:r>
-                  <a:rPr sz="1100" b="1" i="0" baseline="0" dirty="0">
-                    <a:latin typeface="Calibri"/>
-                  </a:rPr>
-                  <a:t> — the descriptive input </a:t>
-                </a:r>
-                <a:r>
-                  <a:rPr lang="en-US" sz="1100" b="1" i="0" baseline="0" dirty="0">
-                    <a:latin typeface="Calibri"/>
-                  </a:rPr>
-                  <a:t>before we pin</a:t>
-                </a:r>
-                <a:r>
-                  <a:rPr lang="en-US" sz="1100" b="1" i="0" dirty="0">
-                    <a:latin typeface="Calibri"/>
-                  </a:rPr>
-                  <a:t> </a:t>
-                </a:r>
-                <a14:m>
-                  <m:oMath xmlns:m="http://schemas.openxmlformats.org/officeDocument/2006/math">
-                    <m:r>
-                      <a:rPr lang="en-US" sz="1100" b="1" i="0" baseline="0" dirty="0" smtClean="0">
-                        <a:latin typeface="Cambria Math" panose="02040503050406030204" pitchFamily="18" charset="0"/>
-                      </a:rPr>
-                      <m:t>𝜌</m:t>
-                    </m:r>
-                  </m:oMath>
-                </a14:m>
-                <a:r>
-                  <a:rPr sz="1100" b="1" i="0" baseline="0" dirty="0">
-                    <a:latin typeface="Calibri"/>
-                  </a:rPr>
-                  <a:t> </a:t>
-                </a:r>
-                <a:r>
-                  <a:rPr lang="en-US" sz="1100" b="1" dirty="0">
-                    <a:latin typeface="Calibri"/>
-                  </a:rPr>
-                  <a:t>and </a:t>
-                </a:r>
-                <a14:m>
-                  <m:oMath xmlns:m="http://schemas.openxmlformats.org/officeDocument/2006/math">
-                    <m:r>
-                      <a:rPr lang="en-US" sz="1100" b="1" i="1" dirty="0" smtClean="0">
-                        <a:latin typeface="Cambria Math" panose="02040503050406030204" pitchFamily="18" charset="0"/>
-                      </a:rPr>
-                      <m:t>𝛾</m:t>
-                    </m:r>
-                  </m:oMath>
-                </a14:m>
-                <a:r>
-                  <a:rPr sz="1100" b="1" i="0" baseline="0" dirty="0">
-                    <a:latin typeface="Calibri"/>
-                  </a:rPr>
-                  <a:t> in sim.</a:t>
-                </a:r>
-              </a:p>
-            </p:txBody>
-          </p:sp>
-        </mc:Choice>
-        <mc:Fallback xmlns="">
-          <p:sp>
-            <p:nvSpPr>
-              <p:cNvPr id="6" name="TextBox 5"/>
-              <p:cNvSpPr txBox="1">
-                <a:spLocks noRot="1" noChangeAspect="1" noMove="1" noResize="1" noEditPoints="1" noAdjustHandles="1" noChangeArrowheads="1" noChangeShapeType="1" noTextEdit="1"/>
-              </p:cNvSpPr>
-              <p:nvPr/>
-            </p:nvSpPr>
-            <p:spPr>
-              <a:xfrm>
-                <a:off x="384048" y="6428472"/>
-                <a:ext cx="11423599" cy="261610"/>
-              </a:xfrm>
-              <a:prstGeom prst="rect">
-                <a:avLst/>
-              </a:prstGeom>
-              <a:blipFill>
-                <a:blip r:embed="rId6"/>
-                <a:stretch>
-                  <a:fillRect b="-14286"/>
-                </a:stretch>
-              </a:blipFill>
-            </p:spPr>
-            <p:txBody>
-              <a:bodyPr/>
-              <a:lstStyle/>
-              <a:p>
-                <a:r>
-                  <a:rPr lang="en-US">
-                    <a:noFill/>
-                  </a:rPr>
-                  <a:t> </a:t>
-                </a:r>
-              </a:p>
-            </p:txBody>
-          </p:sp>
-        </mc:Fallback>
-      </mc:AlternateContent>
+      <p:sp>
+        <p:nvSpPr>
+          <p:cNvPr id="5" name="TextBox 4"/>
+          <p:cNvSpPr txBox="1"/>
+          <p:nvPr/>
+        </p:nvSpPr>
+        <p:spPr>
+          <a:xfrm>
+            <a:off x="384048" y="3849624"/>
+            <a:ext cx="3794760" cy="2148840"/>
+          </a:xfrm>
+          <a:prstGeom prst="rect">
+            <a:avLst/>
+          </a:prstGeom>
+          <a:noFill/>
+        </p:spPr>
+        <p:txBody>
+          <a:bodyPr wrap="square">
+            <a:spAutoFit/>
+          </a:bodyPr>
+          <a:lstStyle/>
+          <a:p>
+            <a:pPr>
+              <a:buChar char="•"/>
+              <a:lnSpc>
+                <a:spcPct val="150000"/>
+              </a:lnSpc>
+              <a:spcBef>
+                <a:spcPts val="0"/>
+              </a:spcBef>
+              <a:spcAft>
+                <a:spcPts val="0"/>
+              </a:spcAft>
+            </a:pPr>
+            <a:r>
+              <a:rPr sz="1000" b="0" i="0" baseline="0">
+                <a:latin typeface="Calibri"/>
+              </a:rPr>
+              <a:t>  Grandchild one-shot league: 2015 PPM z abilities, C=15, J=402.</a:t>
+            </a:r>
+          </a:p>
+          <a:p>
+            <a:pPr>
+              <a:buChar char="•"/>
+              <a:lnSpc>
+                <a:spcPct val="150000"/>
+              </a:lnSpc>
+              <a:spcBef>
+                <a:spcPts val="0"/>
+              </a:spcBef>
+              <a:spcAft>
+                <a:spcPts val="0"/>
+              </a:spcAft>
+            </a:pPr>
+            <a:r>
+              <a:rPr sz="1000" b="0" i="0" baseline="0">
+                <a:latin typeface="Calibri"/>
+              </a:rPr>
+              <a:t>  ASSIGN: \rho=0.5, endogenous \mu_j — no T_{j^*} draw.</a:t>
+            </a:r>
+          </a:p>
+          <a:p>
+            <a:pPr>
+              <a:buChar char="•"/>
+              <a:lnSpc>
+                <a:spcPct val="150000"/>
+              </a:lnSpc>
+              <a:spcBef>
+                <a:spcPts val="0"/>
+              </a:spcBef>
+              <a:spcAft>
+                <a:spcPts val="0"/>
+              </a:spcAft>
+            </a:pPr>
+            <a:r>
+              <a:rPr sz="1000" b="0" i="0" baseline="0">
+                <a:latin typeface="Calibri"/>
+              </a:rPr>
+              <a:t>  H_{sort} = 1 - \sum_i(\hat{A}_i - \hat{\mu}_{g(i)})^2 / \sum_i(\hat{A}_i - \bar{A})^2 — realized sorting on a fixed partition.</a:t>
+            </a:r>
+          </a:p>
+          <a:p>
+            <a:pPr>
+              <a:buChar char="•"/>
+              <a:lnSpc>
+                <a:spcPct val="150000"/>
+              </a:lnSpc>
+              <a:spcBef>
+                <a:spcPts val="0"/>
+              </a:spcBef>
+              <a:spcAft>
+                <a:spcPts val="0"/>
+              </a:spcAft>
+            </a:pPr>
+            <a:r>
+              <a:rPr sz="1000" b="0" i="0" baseline="0">
+                <a:latin typeface="Calibri"/>
+              </a:rPr>
+              <a:t>  Grandchild partition: H_{sort} = 0.157 (0 = none, 1 = full team sorting).</a:t>
+            </a:r>
+          </a:p>
+          <a:p>
+            <a:pPr>
+              <a:buChar char="•"/>
+              <a:lnSpc>
+                <a:spcPct val="150000"/>
+              </a:lnSpc>
+              <a:spcBef>
+                <a:spcPts val="0"/>
+              </a:spcBef>
+              <a:spcAft>
+                <a:spcPts val="0"/>
+              </a:spcAft>
+            </a:pPr>
+            <a:r>
+              <a:rPr sz="1000" b="0" i="0" baseline="0">
+                <a:latin typeface="Calibri"/>
+              </a:rPr>
+              <a:t>  Max coverage=402; sort-and-chop max=8.</a:t>
+            </a:r>
+          </a:p>
+          <a:p>
+            <a:pPr>
+              <a:buChar char="•"/>
+              <a:lnSpc>
+                <a:spcPct val="150000"/>
+              </a:lnSpc>
+              <a:spcBef>
+                <a:spcPts val="0"/>
+              </a:spcBef>
+              <a:spcAft>
+                <a:spcPts val="0"/>
+              </a:spcAft>
+            </a:pPr>
+            <a:r>
+              <a:rPr sz="1000" b="0" i="0" baseline="0">
+                <a:latin typeface="Calibri"/>
+              </a:rPr>
+              <a:t>  Roster span: mean=3.36 z (402 teams).</a:t>
+            </a:r>
+          </a:p>
+          <a:p>
+            <a:pPr>
+              <a:buChar char="•"/>
+              <a:lnSpc>
+                <a:spcPct val="150000"/>
+              </a:lnSpc>
+              <a:spcBef>
+                <a:spcPts val="0"/>
+              </a:spcBef>
+              <a:spcAft>
+                <a:spcPts val="0"/>
+              </a:spcAft>
+            </a:pPr>
+            <a:r>
+              <a:rPr sz="1000" b="0" i="0" baseline="0">
+                <a:latin typeface="Calibri"/>
+              </a:rPr>
+              <a:t>  VECTOR lock: H_{sort} is realized sorting — not the generative homophily knob \rho.</a:t>
+            </a:r>
+          </a:p>
+        </p:txBody>
+      </p:sp>
+      <p:sp>
+        <p:nvSpPr>
+          <p:cNvPr id="6" name="TextBox 5"/>
+          <p:cNvSpPr txBox="1"/>
+          <p:nvPr/>
+        </p:nvSpPr>
+        <p:spPr>
+          <a:xfrm>
+            <a:off x="384048" y="6053328"/>
+            <a:ext cx="11423599" cy="420624"/>
+          </a:xfrm>
+          <a:prstGeom prst="rect">
+            <a:avLst/>
+          </a:prstGeom>
+          <a:noFill/>
+        </p:spPr>
+        <p:txBody>
+          <a:bodyPr wrap="square">
+            <a:spAutoFit/>
+          </a:bodyPr>
+          <a:lstStyle/>
+          <a:p>
+            <a:pPr algn="l"/>
+            <a:r>
+              <a:rPr sz="1100" b="1" i="0" baseline="0">
+                <a:latin typeface="Calibri"/>
+              </a:rPr>
+              <a:t>Claim: Grandchild ASSIGN (_x000D_ho-only, endogenous centroids) on 2015 PPM z — compare interval overlap and H_{sort} to empirical slide 3.</a:t>
+            </a:r>
+          </a:p>
+        </p:txBody>
+      </p:sp>
     </p:spTree>
   </p:cSld>
   <p:clrMapOvr>

</xml_diff>

<commit_message>
Update Grandchild model documentation and outputs
- Enhanced `statistics.json` to reflect updated user and agent message counts, along with revised last updated timestamps for accurate tracking.
- Introduced new markdown files detailing the LG three-step pipeline and its components, including `Alex_LG_three_step_briefing.md` for clarity on the ASSIGN, SCORE, and SELECT processes.
- Added new empirical data files and visualizations, including `MLE_prob.docx` and `PD19_board.jpeg`, to support ongoing analyses and presentations.
- Updated existing scripts to improve color palette handling for lambda sweeps, ensuring clearer visual outputs.

These changes strengthen the analytical framework for the Grandchild model, providing valuable insights into player selection dynamics and supporting future presentations.
</commit_message>
<xml_diff>
--- a/3-Master_Plan/re_entry/HEROs_and_PASSes/slides/CHAR_PD17_HAND.pptx
+++ b/3-Master_Plan/re_entry/HEROs_and_PASSes/slides/CHAR_PD17_HAND.pptx
@@ -5917,8 +5917,8 @@
             </p:nvSpPr>
             <p:spPr>
               <a:xfrm>
-                <a:off x="6984337" y="1264044"/>
-                <a:ext cx="4411913" cy="5146794"/>
+                <a:off x="6908535" y="1393171"/>
+                <a:ext cx="4411913" cy="4089196"/>
               </a:xfrm>
               <a:prstGeom prst="rect">
                 <a:avLst/>
@@ -5931,43 +5931,30 @@
               </a:bodyPr>
               <a:lstStyle/>
               <a:p>
-                <a:pPr>
-                  <a:lnSpc>
-                    <a:spcPct val="150000"/>
-                  </a:lnSpc>
-                </a:pPr>
-                <a:r>
-                  <a:rPr lang="en-US" sz="1000" b="0" i="0" baseline="0" dirty="0">
-                    <a:latin typeface="Calibri"/>
-                  </a:rPr>
+                <a:r>
+                  <a:rPr lang="en-US" sz="1100" b="1" dirty="0"/>
                   <a:t>Block A — Empirical inputs &amp; overlap</a:t>
                 </a:r>
-              </a:p>
-              <a:p>
-                <a:pPr lvl="1">
-                  <a:lnSpc>
-                    <a:spcPct val="150000"/>
-                  </a:lnSpc>
-                </a:pPr>
-                <a:r>
-                  <a:rPr lang="en-US" sz="1000" b="0" i="0" baseline="0" dirty="0">
-                    <a:latin typeface="Calibri"/>
-                  </a:rPr>
-                  <a:t>Slide 2 — </a:t>
+                <a:br>
+                  <a:rPr lang="en-US" sz="1100" dirty="0"/>
+                </a:br>
+                <a:r>
+                  <a:rPr lang="en-US" sz="1100" dirty="0"/>
+                  <a:t>	2 · </a:t>
                 </a:r>
                 <a14:m>
                   <m:oMath xmlns:m="http://schemas.openxmlformats.org/officeDocument/2006/math">
                     <m:sSub>
                       <m:sSubPr>
                         <m:ctrlPr>
-                          <a:rPr lang="en-US" sz="1000" b="0" i="0" baseline="0" dirty="0" err="1" smtClean="0">
+                          <a:rPr lang="en-US" sz="1100" i="1" dirty="0" smtClean="0">
                             <a:latin typeface="Cambria Math" panose="02040503050406030204" pitchFamily="18" charset="0"/>
                           </a:rPr>
                         </m:ctrlPr>
                       </m:sSubPr>
                       <m:e>
                         <m:r>
-                          <a:rPr lang="en-US" sz="1000" b="0" i="0" baseline="0" dirty="0" err="1" smtClean="0">
+                          <a:rPr lang="en-US" sz="1100" i="1" dirty="0" smtClean="0">
                             <a:latin typeface="Cambria Math" panose="02040503050406030204" pitchFamily="18" charset="0"/>
                           </a:rPr>
                           <m:t>Â</m:t>
@@ -5975,40 +5962,622 @@
                       </m:e>
                       <m:sub>
                         <m:r>
-                          <a:rPr lang="en-US" sz="1000" b="0" i="0" baseline="0" dirty="0" err="1" smtClean="0">
+                          <a:rPr lang="en-US" sz="1100" i="1" dirty="0" smtClean="0">
                             <a:latin typeface="Cambria Math" panose="02040503050406030204" pitchFamily="18" charset="0"/>
                           </a:rPr>
                           <m:t>𝑖</m:t>
                         </m:r>
                       </m:sub>
                     </m:sSub>
-                  </m:oMath>
-                </a14:m>
-                <a:r>
-                  <a:rPr lang="en-US" sz="1000" b="0" i="0" baseline="0" dirty="0">
-                    <a:latin typeface="Calibri"/>
-                  </a:rPr>
-                  <a:t>, </a:t>
-                </a:r>
-                <a14:m>
-                  <m:oMath xmlns:m="http://schemas.openxmlformats.org/officeDocument/2006/math">
-                    <m:r>
-                      <a:rPr lang="en-US" sz="1000" b="0" i="0" baseline="0" dirty="0" smtClean="0">
-                        <a:latin typeface="Cambria Math" panose="02040503050406030204" pitchFamily="18" charset="0"/>
-                      </a:rPr>
-                      <m:t>𝑇</m:t>
+                    <m:r>
+                      <a:rPr lang="en-US" sz="1100" i="1" dirty="0" smtClean="0">
+                        <a:latin typeface="Cambria Math" panose="02040503050406030204" pitchFamily="18" charset="0"/>
+                      </a:rPr>
+                      <m:t>, </m:t>
                     </m:r>
                     <m:sSub>
                       <m:sSubPr>
                         <m:ctrlPr>
-                          <a:rPr lang="en-US" sz="1000" b="0" i="0" baseline="0" dirty="0" err="1" smtClean="0">
+                          <a:rPr lang="en-US" sz="1100" i="1" dirty="0" err="1" smtClean="0">
+                            <a:latin typeface="Cambria Math" panose="02040503050406030204" pitchFamily="18" charset="0"/>
+                          </a:rPr>
+                        </m:ctrlPr>
+                      </m:sSubPr>
+                      <m:e>
+                        <m:acc>
+                          <m:accPr>
+                            <m:chr m:val="̂"/>
+                            <m:ctrlPr>
+                              <a:rPr lang="en-US" sz="1100" i="1" dirty="0" err="1" smtClean="0">
+                                <a:latin typeface="Cambria Math" panose="02040503050406030204" pitchFamily="18" charset="0"/>
+                              </a:rPr>
+                            </m:ctrlPr>
+                          </m:accPr>
+                          <m:e>
+                            <m:r>
+                              <a:rPr lang="en-US" sz="1100" i="1" dirty="0" err="1" smtClean="0">
+                                <a:latin typeface="Cambria Math" panose="02040503050406030204" pitchFamily="18" charset="0"/>
+                              </a:rPr>
+                              <m:t>𝑇</m:t>
+                            </m:r>
+                          </m:e>
+                        </m:acc>
+                      </m:e>
+                      <m:sub>
+                        <m:r>
+                          <a:rPr lang="en-US" sz="1100" i="1" dirty="0" err="1" smtClean="0">
+                            <a:latin typeface="Cambria Math" panose="02040503050406030204" pitchFamily="18" charset="0"/>
+                          </a:rPr>
+                          <m:t>𝑗</m:t>
+                        </m:r>
+                      </m:sub>
+                    </m:sSub>
+                  </m:oMath>
+                </a14:m>
+                <a:r>
+                  <a:rPr lang="en-US" sz="1100" dirty="0"/>
+                  <a:t>inputs (2011–2021)</a:t>
+                </a:r>
+                <a:br>
+                  <a:rPr lang="en-US" sz="1100" dirty="0"/>
+                </a:br>
+                <a:r>
+                  <a:rPr lang="en-US" sz="1100" dirty="0"/>
+                  <a:t>	3 · NCAA interval overlap (full panel)</a:t>
+                </a:r>
+                <a:br>
+                  <a:rPr lang="en-US" sz="1100" dirty="0"/>
+                </a:br>
+                <a:r>
+                  <a:rPr lang="en-US" sz="1100" dirty="0"/>
+                  <a:t>	4–5 · NCAA vs LG intervals (2015–2019 window)</a:t>
+                </a:r>
+              </a:p>
+              <a:p>
+                <a:r>
+                  <a:rPr lang="en-US" sz="1100" b="1" dirty="0"/>
+                  <a:t>Block B — LG </a:t>
+                </a:r>
+                <a14:m>
+                  <m:oMath xmlns:m="http://schemas.openxmlformats.org/officeDocument/2006/math">
+                    <m:r>
+                      <a:rPr lang="en-US" sz="1100" b="1" i="1" dirty="0" smtClean="0">
+                        <a:latin typeface="Cambria Math" panose="02040503050406030204" pitchFamily="18" charset="0"/>
+                      </a:rPr>
+                      <m:t>𝜌</m:t>
+                    </m:r>
+                  </m:oMath>
+                </a14:m>
+                <a:r>
+                  <a:rPr lang="en-US" sz="1100" b="1" dirty="0"/>
+                  <a:t> validation (ASSIGN)</a:t>
+                </a:r>
+                <a:br>
+                  <a:rPr lang="en-US" sz="1100" dirty="0"/>
+                </a:br>
+                <a:r>
+                  <a:rPr lang="en-US" sz="1100" dirty="0"/>
+                  <a:t>	6 · global_wss vs </a:t>
+                </a:r>
+                <a14:m>
+                  <m:oMath xmlns:m="http://schemas.openxmlformats.org/officeDocument/2006/math">
+                    <m:r>
+                      <a:rPr lang="en-US" sz="1100" i="1" dirty="0" smtClean="0">
+                        <a:latin typeface="Cambria Math" panose="02040503050406030204" pitchFamily="18" charset="0"/>
+                      </a:rPr>
+                      <m:t>𝜌</m:t>
+                    </m:r>
+                  </m:oMath>
+                </a14:m>
+                <a:r>
+                  <a:rPr lang="en-US" sz="1100" dirty="0"/>
+                  <a:t> (primary)</a:t>
+                </a:r>
+                <a:br>
+                  <a:rPr lang="en-US" sz="1100" dirty="0"/>
+                </a:br>
+                <a:r>
+                  <a:rPr lang="en-US" sz="1100" dirty="0"/>
+                  <a:t>	7 · </a:t>
+                </a:r>
+                <a14:m>
+                  <m:oMath xmlns:m="http://schemas.openxmlformats.org/officeDocument/2006/math">
+                    <m:sSub>
+                      <m:sSubPr>
+                        <m:ctrlPr>
+                          <a:rPr lang="en-US" sz="1100" i="1" dirty="0" smtClean="0">
                             <a:latin typeface="Cambria Math" panose="02040503050406030204" pitchFamily="18" charset="0"/>
                           </a:rPr>
                         </m:ctrlPr>
                       </m:sSubPr>
                       <m:e>
                         <m:r>
-                          <a:rPr lang="en-US" sz="1000" b="0" i="0" baseline="0" dirty="0" err="1" smtClean="0">
+                          <a:rPr lang="en-US" sz="1100" i="1" dirty="0" smtClean="0">
+                            <a:latin typeface="Cambria Math" panose="02040503050406030204" pitchFamily="18" charset="0"/>
+                          </a:rPr>
+                          <m:t>𝐻</m:t>
+                        </m:r>
+                      </m:e>
+                      <m:sub>
+                        <m:r>
+                          <a:rPr lang="en-US" sz="1100" i="1" dirty="0" smtClean="0">
+                            <a:latin typeface="Cambria Math" panose="02040503050406030204" pitchFamily="18" charset="0"/>
+                          </a:rPr>
+                          <m:t>𝑠𝑜𝑟𝑡</m:t>
+                        </m:r>
+                      </m:sub>
+                    </m:sSub>
+                  </m:oMath>
+                </a14:m>
+                <a:r>
+                  <a:rPr lang="en-US" sz="1100" dirty="0"/>
+                  <a:t> glossary + </a:t>
+                </a:r>
+                <a14:m>
+                  <m:oMath xmlns:m="http://schemas.openxmlformats.org/officeDocument/2006/math">
+                    <m:r>
+                      <a:rPr lang="en-US" sz="1100" i="1" dirty="0" smtClean="0">
+                        <a:latin typeface="Cambria Math" panose="02040503050406030204" pitchFamily="18" charset="0"/>
+                      </a:rPr>
+                      <m:t>𝜌</m:t>
+                    </m:r>
+                  </m:oMath>
+                </a14:m>
+                <a:r>
+                  <a:rPr lang="en-US" sz="1100" dirty="0"/>
+                  <a:t> inset</a:t>
+                </a:r>
+              </a:p>
+              <a:p>
+                <a:r>
+                  <a:rPr lang="en-US" sz="1100" b="1" dirty="0"/>
+                  <a:t>Block C — Team </a:t>
+                </a:r>
+                <a14:m>
+                  <m:oMath xmlns:m="http://schemas.openxmlformats.org/officeDocument/2006/math">
+                    <m:sSub>
+                      <m:sSubPr>
+                        <m:ctrlPr>
+                          <a:rPr lang="en-US" sz="1100" b="1" i="1" dirty="0" smtClean="0">
+                            <a:latin typeface="Cambria Math" panose="02040503050406030204" pitchFamily="18" charset="0"/>
+                          </a:rPr>
+                        </m:ctrlPr>
+                      </m:sSubPr>
+                      <m:e>
+                        <m:r>
+                          <a:rPr lang="en-US" sz="1100" b="1" i="1" dirty="0" smtClean="0">
+                            <a:latin typeface="Cambria Math" panose="02040503050406030204" pitchFamily="18" charset="0"/>
+                          </a:rPr>
+                          <m:t>𝑳</m:t>
+                        </m:r>
+                      </m:e>
+                      <m:sub>
+                        <m:r>
+                          <a:rPr lang="en-US" sz="1100" b="1" i="1" dirty="0" smtClean="0">
+                            <a:latin typeface="Cambria Math" panose="02040503050406030204" pitchFamily="18" charset="0"/>
+                          </a:rPr>
+                          <m:t>𝑪</m:t>
+                        </m:r>
+                      </m:sub>
+                    </m:sSub>
+                  </m:oMath>
+                </a14:m>
+                <a:r>
+                  <a:rPr lang="en-US" sz="1100" b="1" dirty="0"/>
+                  <a:t> on real rosters (SCORE input)</a:t>
+                </a:r>
+                <a:br>
+                  <a:rPr lang="en-US" sz="1100" dirty="0"/>
+                </a:br>
+                <a:r>
+                  <a:rPr lang="en-US" sz="1100" dirty="0"/>
+                  <a:t>	8 · Empirical team </a:t>
+                </a:r>
+                <a14:m>
+                  <m:oMath xmlns:m="http://schemas.openxmlformats.org/officeDocument/2006/math">
+                    <m:sSub>
+                      <m:sSubPr>
+                        <m:ctrlPr>
+                          <a:rPr lang="en-US" sz="1100" i="1" dirty="0" smtClean="0">
+                            <a:latin typeface="Cambria Math" panose="02040503050406030204" pitchFamily="18" charset="0"/>
+                          </a:rPr>
+                        </m:ctrlPr>
+                      </m:sSubPr>
+                      <m:e>
+                        <m:r>
+                          <a:rPr lang="en-US" sz="1100" i="1" dirty="0" smtClean="0">
+                            <a:latin typeface="Cambria Math" panose="02040503050406030204" pitchFamily="18" charset="0"/>
+                          </a:rPr>
+                          <m:t>𝐿</m:t>
+                        </m:r>
+                      </m:e>
+                      <m:sub>
+                        <m:r>
+                          <a:rPr lang="en-US" sz="1100" i="1" dirty="0" smtClean="0">
+                            <a:latin typeface="Cambria Math" panose="02040503050406030204" pitchFamily="18" charset="0"/>
+                          </a:rPr>
+                          <m:t>𝐶</m:t>
+                        </m:r>
+                      </m:sub>
+                    </m:sSub>
+                    <m:d>
+                      <m:dPr>
+                        <m:ctrlPr>
+                          <a:rPr lang="en-US" sz="1100" i="1" dirty="0" smtClean="0">
+                            <a:latin typeface="Cambria Math" panose="02040503050406030204" pitchFamily="18" charset="0"/>
+                          </a:rPr>
+                        </m:ctrlPr>
+                      </m:dPr>
+                      <m:e>
+                        <m:r>
+                          <a:rPr lang="en-US" sz="1100" i="1" dirty="0" smtClean="0">
+                            <a:latin typeface="Cambria Math" panose="02040503050406030204" pitchFamily="18" charset="0"/>
+                          </a:rPr>
+                          <m:t>𝛾</m:t>
+                        </m:r>
+                        <m:r>
+                          <a:rPr lang="en-US" sz="1100" i="1" dirty="0" smtClean="0">
+                            <a:latin typeface="Cambria Math" panose="02040503050406030204" pitchFamily="18" charset="0"/>
+                          </a:rPr>
+                          <m:t>=0.5</m:t>
+                        </m:r>
+                      </m:e>
+                    </m:d>
+                  </m:oMath>
+                </a14:m>
+                <a:endParaRPr lang="en-US" sz="1100" b="1" dirty="0"/>
+              </a:p>
+              <a:p>
+                <a:r>
+                  <a:rPr lang="en-US" sz="1100" b="1" dirty="0"/>
+                  <a:t>Block D — LG input comparability (empirical caps, </a:t>
+                </a:r>
+                <a14:m>
+                  <m:oMath xmlns:m="http://schemas.openxmlformats.org/officeDocument/2006/math">
+                    <m:r>
+                      <a:rPr lang="en-US" sz="1100" b="1" i="1" dirty="0" smtClean="0">
+                        <a:latin typeface="Cambria Math" panose="02040503050406030204" pitchFamily="18" charset="0"/>
+                      </a:rPr>
+                      <m:t>𝜌</m:t>
+                    </m:r>
+                    <m:r>
+                      <a:rPr lang="en-US" sz="1100" b="1" i="0" dirty="0" err="1">
+                        <a:latin typeface="Cambria Math" panose="02040503050406030204" pitchFamily="18" charset="0"/>
+                      </a:rPr>
+                      <m:t>=0.5</m:t>
+                    </m:r>
+                  </m:oMath>
+                </a14:m>
+                <a:r>
+                  <a:rPr lang="en-US" sz="1100" b="1" dirty="0"/>
+                  <a:t>)</a:t>
+                </a:r>
+                <a:br>
+                  <a:rPr lang="en-US" sz="1100" dirty="0"/>
+                </a:br>
+                <a:r>
+                  <a:rPr lang="en-US" sz="1100" dirty="0"/>
+                  <a:t>	9 · Roster-size multiset (Alex caps fix)</a:t>
+                </a:r>
+                <a:br>
+                  <a:rPr lang="en-US" sz="1100" dirty="0"/>
+                </a:br>
+                <a:r>
+                  <a:rPr lang="en-US" sz="1100" dirty="0"/>
+                  <a:t>	10 · Team </a:t>
+                </a:r>
+                <a14:m>
+                  <m:oMath xmlns:m="http://schemas.openxmlformats.org/officeDocument/2006/math">
+                    <m:sSub>
+                      <m:sSubPr>
+                        <m:ctrlPr>
+                          <a:rPr lang="en-US" sz="1100" i="1" dirty="0">
+                            <a:latin typeface="Cambria Math" panose="02040503050406030204" pitchFamily="18" charset="0"/>
+                          </a:rPr>
+                        </m:ctrlPr>
+                      </m:sSubPr>
+                      <m:e>
+                        <m:r>
+                          <a:rPr lang="en-US" sz="1100" i="1" dirty="0">
+                            <a:latin typeface="Cambria Math" panose="02040503050406030204" pitchFamily="18" charset="0"/>
+                          </a:rPr>
+                          <m:t>𝐿</m:t>
+                        </m:r>
+                      </m:e>
+                      <m:sub>
+                        <m:r>
+                          <a:rPr lang="en-US" sz="1100" i="1" dirty="0">
+                            <a:latin typeface="Cambria Math" panose="02040503050406030204" pitchFamily="18" charset="0"/>
+                          </a:rPr>
+                          <m:t>𝐶</m:t>
+                        </m:r>
+                      </m:sub>
+                    </m:sSub>
+                  </m:oMath>
+                </a14:m>
+                <a:r>
+                  <a:rPr lang="en-US" sz="1100" dirty="0"/>
+                  <a:t> vs NCAA (</a:t>
+                </a:r>
+                <a14:m>
+                  <m:oMath xmlns:m="http://schemas.openxmlformats.org/officeDocument/2006/math">
+                    <m:r>
+                      <a:rPr lang="en-US" sz="1100" dirty="0" smtClean="0">
+                        <a:latin typeface="Cambria Math" panose="02040503050406030204" pitchFamily="18" charset="0"/>
+                      </a:rPr>
+                      <m:t>6</m:t>
+                    </m:r>
+                    <m:r>
+                      <a:rPr lang="en-US" sz="1100" i="0" dirty="0">
+                        <a:latin typeface="Cambria Math" panose="02040503050406030204" pitchFamily="18" charset="0"/>
+                      </a:rPr>
+                      <m:t>,492</m:t>
+                    </m:r>
+                  </m:oMath>
+                </a14:m>
+                <a:r>
+                  <a:rPr lang="en-US" sz="1100" dirty="0"/>
+                  <a:t> team-seasons)</a:t>
+                </a:r>
+                <a:br>
+                  <a:rPr lang="en-US" sz="1100" dirty="0"/>
+                </a:br>
+                <a:r>
+                  <a:rPr lang="en-US" sz="1100" dirty="0"/>
+                  <a:t>	11 · SELECT vs Hero — caps alone ≠ inverted-U → </a:t>
+                </a:r>
+                <a14:m>
+                  <m:oMath xmlns:m="http://schemas.openxmlformats.org/officeDocument/2006/math">
+                    <m:r>
+                      <a:rPr lang="en-US" sz="1100" i="1" dirty="0" smtClean="0">
+                        <a:latin typeface="Cambria Math" panose="02040503050406030204" pitchFamily="18" charset="0"/>
+                      </a:rPr>
+                      <m:t>𝜆</m:t>
+                    </m:r>
+                  </m:oMath>
+                </a14:m>
+                <a:r>
+                  <a:rPr lang="en-US" sz="1100" dirty="0"/>
+                  <a:t> sweep</a:t>
+                </a:r>
+              </a:p>
+              <a:p>
+                <a:r>
+                  <a:rPr lang="en-US" sz="1100" b="1" dirty="0"/>
+                  <a:t>Block E — Hero &amp; sensitivity (empirical)</a:t>
+                </a:r>
+                <a:br>
+                  <a:rPr lang="en-US" sz="1100" dirty="0"/>
+                </a:br>
+                <a:r>
+                  <a:rPr lang="en-US" sz="1100" dirty="0"/>
+                  <a:t>	12 · NCAA roster sizes vs fixed </a:t>
+                </a:r>
+                <a14:m>
+                  <m:oMath xmlns:m="http://schemas.openxmlformats.org/officeDocument/2006/math">
+                    <m:r>
+                      <a:rPr lang="en-US" sz="1100" i="1" dirty="0" smtClean="0">
+                        <a:latin typeface="Cambria Math" panose="02040503050406030204" pitchFamily="18" charset="0"/>
+                      </a:rPr>
+                      <m:t>𝐶</m:t>
+                    </m:r>
+                    <m:r>
+                      <a:rPr lang="en-US" sz="1100" i="0" dirty="0">
+                        <a:latin typeface="Cambria Math" panose="02040503050406030204" pitchFamily="18" charset="0"/>
+                      </a:rPr>
+                      <m:t>=15</m:t>
+                    </m:r>
+                  </m:oMath>
+                </a14:m>
+                <a:br>
+                  <a:rPr lang="en-US" sz="1100" dirty="0"/>
+                </a:br>
+                <a:r>
+                  <a:rPr lang="en-US" sz="1100" dirty="0"/>
+                  <a:t>	13–14 · min_minutes ladder (Hero robustness)</a:t>
+                </a:r>
+                <a:br>
+                  <a:rPr lang="en-US" sz="1100" dirty="0"/>
+                </a:br>
+                <a:r>
+                  <a:rPr lang="en-US" sz="1100" dirty="0"/>
+                  <a:t>	15–16 · LG </a:t>
+                </a:r>
+                <a14:m>
+                  <m:oMath xmlns:m="http://schemas.openxmlformats.org/officeDocument/2006/math">
+                    <m:r>
+                      <a:rPr lang="en-US" sz="1100" i="1" dirty="0" smtClean="0">
+                        <a:latin typeface="Cambria Math" panose="02040503050406030204" pitchFamily="18" charset="0"/>
+                      </a:rPr>
+                      <m:t>𝐶</m:t>
+                    </m:r>
+                  </m:oMath>
+                </a14:m>
+                <a:r>
+                  <a:rPr lang="en-US" sz="1100" dirty="0"/>
+                  <a:t> sweep (</a:t>
+                </a:r>
+                <a14:m>
+                  <m:oMath xmlns:m="http://schemas.openxmlformats.org/officeDocument/2006/math">
+                    <m:sSub>
+                      <m:sSubPr>
+                        <m:ctrlPr>
+                          <a:rPr lang="en-US" sz="1100" i="1" dirty="0">
+                            <a:latin typeface="Cambria Math" panose="02040503050406030204" pitchFamily="18" charset="0"/>
+                          </a:rPr>
+                        </m:ctrlPr>
+                      </m:sSubPr>
+                      <m:e>
+                        <m:r>
+                          <a:rPr lang="en-US" sz="1100" i="1" dirty="0">
+                            <a:latin typeface="Cambria Math" panose="02040503050406030204" pitchFamily="18" charset="0"/>
+                          </a:rPr>
+                          <m:t>𝐿</m:t>
+                        </m:r>
+                      </m:e>
+                      <m:sub>
+                        <m:r>
+                          <a:rPr lang="en-US" sz="1100" i="1" dirty="0">
+                            <a:latin typeface="Cambria Math" panose="02040503050406030204" pitchFamily="18" charset="0"/>
+                          </a:rPr>
+                          <m:t>𝐶</m:t>
+                        </m:r>
+                      </m:sub>
+                    </m:sSub>
+                  </m:oMath>
+                </a14:m>
+                <a:r>
+                  <a:rPr lang="en-US" sz="1100" dirty="0"/>
+                  <a:t> + SELECT; monotone)</a:t>
+                </a:r>
+              </a:p>
+              <a:p>
+                <a:r>
+                  <a:rPr lang="en-US" sz="1100" b="1" dirty="0"/>
+                  <a:t>Block F — </a:t>
+                </a:r>
+                <a14:m>
+                  <m:oMath xmlns:m="http://schemas.openxmlformats.org/officeDocument/2006/math">
+                    <m:r>
+                      <a:rPr lang="en-US" sz="1100" b="1" i="1" dirty="0" smtClean="0">
+                        <a:latin typeface="Cambria Math" panose="02040503050406030204" pitchFamily="18" charset="0"/>
+                      </a:rPr>
+                      <m:t>𝜆</m:t>
+                    </m:r>
+                  </m:oMath>
+                </a14:m>
+                <a:r>
+                  <a:rPr lang="en-US" sz="1100" b="1" dirty="0"/>
+                  <a:t> in SCORE (LG, empirical caps held fixed)</a:t>
+                </a:r>
+                <a:br>
+                  <a:rPr lang="en-US" sz="1100" dirty="0"/>
+                </a:br>
+                <a:r>
+                  <a:rPr lang="en-US" sz="1100" dirty="0"/>
+                  <a:t>	20 · </a:t>
+                </a:r>
+                <a14:m>
+                  <m:oMath xmlns:m="http://schemas.openxmlformats.org/officeDocument/2006/math">
+                    <m:r>
+                      <a:rPr lang="en-US" sz="1100" i="1" dirty="0" smtClean="0">
+                        <a:latin typeface="Cambria Math" panose="02040503050406030204" pitchFamily="18" charset="0"/>
+                      </a:rPr>
+                      <m:t>𝜆</m:t>
+                    </m:r>
+                  </m:oMath>
+                </a14:m>
+                <a:r>
+                  <a:rPr lang="en-US" sz="1100" dirty="0"/>
+                  <a:t> fine grid (flip </a:t>
+                </a:r>
+                <a14:m>
+                  <m:oMath xmlns:m="http://schemas.openxmlformats.org/officeDocument/2006/math">
+                    <m:r>
+                      <a:rPr lang="en-US" sz="1100" dirty="0" smtClean="0">
+                        <a:latin typeface="Cambria Math" panose="02040503050406030204" pitchFamily="18" charset="0"/>
+                      </a:rPr>
+                      <m:t>1.25</m:t>
+                    </m:r>
+                    <m:r>
+                      <a:rPr lang="en-US" sz="1100" i="0" dirty="0">
+                        <a:latin typeface="Cambria Math" panose="02040503050406030204" pitchFamily="18" charset="0"/>
+                      </a:rPr>
+                      <m:t>→1.5</m:t>
+                    </m:r>
+                  </m:oMath>
+                </a14:m>
+                <a:r>
+                  <a:rPr lang="en-US" sz="1100" dirty="0"/>
+                  <a:t>; peak bin </a:t>
+                </a:r>
+                <a14:m>
+                  <m:oMath xmlns:m="http://schemas.openxmlformats.org/officeDocument/2006/math">
+                    <m:r>
+                      <a:rPr lang="en-US" sz="1100" dirty="0" smtClean="0">
+                        <a:latin typeface="Cambria Math" panose="02040503050406030204" pitchFamily="18" charset="0"/>
+                      </a:rPr>
+                      <m:t>11</m:t>
+                    </m:r>
+                  </m:oMath>
+                </a14:m>
+                <a:r>
+                  <a:rPr lang="en-US" sz="1100" dirty="0"/>
+                  <a:t> at </a:t>
+                </a:r>
+                <a14:m>
+                  <m:oMath xmlns:m="http://schemas.openxmlformats.org/officeDocument/2006/math">
+                    <m:r>
+                      <a:rPr lang="en-US" sz="1100" i="1" dirty="0" smtClean="0">
+                        <a:latin typeface="Cambria Math" panose="02040503050406030204" pitchFamily="18" charset="0"/>
+                      </a:rPr>
+                      <m:t>𝜆</m:t>
+                    </m:r>
+                    <m:r>
+                      <a:rPr lang="en-US" sz="1100" i="0" dirty="0" err="1">
+                        <a:latin typeface="Cambria Math" panose="02040503050406030204" pitchFamily="18" charset="0"/>
+                      </a:rPr>
+                      <m:t>≈2–3</m:t>
+                    </m:r>
+                  </m:oMath>
+                </a14:m>
+                <a:r>
+                  <a:rPr lang="en-US" sz="1100" dirty="0"/>
+                  <a:t>)</a:t>
+                </a:r>
+                <a:br>
+                  <a:rPr lang="en-US" sz="1100" dirty="0"/>
+                </a:br>
+                <a:r>
+                  <a:rPr lang="en-US" sz="1100" dirty="0"/>
+                  <a:t>	21 · </a:t>
+                </a:r>
+                <a14:m>
+                  <m:oMath xmlns:m="http://schemas.openxmlformats.org/officeDocument/2006/math">
+                    <m:r>
+                      <a:rPr lang="en-US" sz="1100" i="1" dirty="0" smtClean="0">
+                        <a:latin typeface="Cambria Math" panose="02040503050406030204" pitchFamily="18" charset="0"/>
+                      </a:rPr>
+                      <m:t>𝜆</m:t>
+                    </m:r>
+                  </m:oMath>
+                </a14:m>
+                <a:r>
+                  <a:rPr lang="en-US" sz="1100" dirty="0"/>
+                  <a:t> extended grid</a:t>
+                </a:r>
+              </a:p>
+              <a:p>
+                <a:r>
+                  <a:rPr lang="en-US" sz="1100" b="1" dirty="0"/>
+                  <a:t>Block G — Empirical SCORE diagnostics (PD17)</a:t>
+                </a:r>
+                <a:br>
+                  <a:rPr lang="en-US" sz="1100" dirty="0"/>
+                </a:br>
+                <a:r>
+                  <a:rPr lang="en-US" sz="1100" dirty="0"/>
+                  <a:t>	22 · Sketch A: </a:t>
+                </a:r>
+                <a14:m>
+                  <m:oMath xmlns:m="http://schemas.openxmlformats.org/officeDocument/2006/math">
+                    <m:r>
+                      <a:rPr lang="en-US" sz="1100" i="1" dirty="0" smtClean="0">
+                        <a:latin typeface="Cambria Math" panose="02040503050406030204" pitchFamily="18" charset="0"/>
+                      </a:rPr>
+                      <m:t>𝑇</m:t>
+                    </m:r>
+                    <m:sSub>
+                      <m:sSubPr>
+                        <m:ctrlPr>
+                          <a:rPr lang="en-US" sz="1100" i="0" dirty="0" err="1">
+                            <a:latin typeface="Cambria Math" panose="02040503050406030204" pitchFamily="18" charset="0"/>
+                          </a:rPr>
+                        </m:ctrlPr>
+                      </m:sSubPr>
+                      <m:e>
+                        <m:r>
+                          <a:rPr lang="en-US" sz="1100" i="0" dirty="0" err="1">
                             <a:latin typeface="Cambria Math" panose="02040503050406030204" pitchFamily="18" charset="0"/>
                           </a:rPr>
                           <m:t>̂</m:t>
@@ -6016,7 +6585,7 @@
                       </m:e>
                       <m:sub>
                         <m:r>
-                          <a:rPr lang="en-US" sz="1000" b="0" i="0" baseline="0" dirty="0" err="1" smtClean="0">
+                          <a:rPr lang="en-US" sz="1100" i="1" dirty="0" err="1">
                             <a:latin typeface="Cambria Math" panose="02040503050406030204" pitchFamily="18" charset="0"/>
                           </a:rPr>
                           <m:t>𝑗</m:t>
@@ -6026,48 +6595,58 @@
                   </m:oMath>
                 </a14:m>
                 <a:r>
-                  <a:rPr lang="en-US" sz="1000" b="0" i="0" baseline="0" dirty="0">
-                    <a:latin typeface="Calibri"/>
-                  </a:rPr>
-                  <a:t> inputs (2011–2021 panel)</a:t>
-                </a:r>
-              </a:p>
-              <a:p>
-                <a:pPr lvl="1">
-                  <a:lnSpc>
-                    <a:spcPct val="150000"/>
-                  </a:lnSpc>
-                </a:pPr>
-                <a:r>
-                  <a:rPr lang="en-US" sz="1000" b="0" i="0" baseline="0" dirty="0">
-                    <a:latin typeface="Calibri"/>
-                  </a:rPr>
-                  <a:t>Slide 3 — NCAA interval overlap, full panel (</a:t>
-                </a:r>
-                <a:r>
-                  <a:rPr lang="el-GR" sz="1000" b="0" i="0" baseline="0" dirty="0">
-                    <a:latin typeface="Calibri"/>
-                  </a:rPr>
-                  <a:t>ρ </a:t>
-                </a:r>
-                <a:r>
-                  <a:rPr lang="en-US" sz="1000" b="0" i="0" baseline="0" dirty="0">
-                    <a:latin typeface="Calibri"/>
-                  </a:rPr>
-                  <a:t>diagnostic)</a:t>
-                </a:r>
-              </a:p>
-              <a:p>
-                <a:pPr lvl="1">
-                  <a:lnSpc>
-                    <a:spcPct val="150000"/>
-                  </a:lnSpc>
-                </a:pPr>
-                <a:r>
-                  <a:rPr lang="en-US" sz="1000" b="0" i="0" baseline="0" dirty="0">
-                    <a:latin typeface="Calibri"/>
-                  </a:rPr>
-                  <a:t>Slides 4–5 — NCAA vs LG interval pair (2015–2019 window)</a:t>
+                  <a:rPr lang="en-US" sz="1100" dirty="0"/>
+                  <a:t> vs </a:t>
+                </a:r>
+                <a14:m>
+                  <m:oMath xmlns:m="http://schemas.openxmlformats.org/officeDocument/2006/math">
+                    <m:sSub>
+                      <m:sSubPr>
+                        <m:ctrlPr>
+                          <a:rPr lang="en-US" sz="1100" i="1" dirty="0">
+                            <a:latin typeface="Cambria Math" panose="02040503050406030204" pitchFamily="18" charset="0"/>
+                          </a:rPr>
+                        </m:ctrlPr>
+                      </m:sSubPr>
+                      <m:e>
+                        <m:r>
+                          <a:rPr lang="en-US" sz="1100" i="1" dirty="0">
+                            <a:latin typeface="Cambria Math" panose="02040503050406030204" pitchFamily="18" charset="0"/>
+                          </a:rPr>
+                          <m:t>𝐿</m:t>
+                        </m:r>
+                      </m:e>
+                      <m:sub>
+                        <m:r>
+                          <a:rPr lang="en-US" sz="1100" i="1" dirty="0">
+                            <a:latin typeface="Cambria Math" panose="02040503050406030204" pitchFamily="18" charset="0"/>
+                          </a:rPr>
+                          <m:t>𝐶</m:t>
+                        </m:r>
+                      </m:sub>
+                    </m:sSub>
+                  </m:oMath>
+                </a14:m>
+                <a:br>
+                  <a:rPr lang="en-US" sz="1100" dirty="0"/>
+                </a:br>
+                <a:r>
+                  <a:rPr lang="en-US" sz="1100" dirty="0"/>
+                  <a:t>	23 · </a:t>
+                </a:r>
+                <a14:m>
+                  <m:oMath xmlns:m="http://schemas.openxmlformats.org/officeDocument/2006/math">
+                    <m:r>
+                      <a:rPr lang="en-US" sz="1100" i="1" dirty="0" smtClean="0">
+                        <a:latin typeface="Cambria Math" panose="02040503050406030204" pitchFamily="18" charset="0"/>
+                      </a:rPr>
+                      <m:t>𝛾</m:t>
+                    </m:r>
+                  </m:oMath>
+                </a14:m>
+                <a:r>
+                  <a:rPr lang="en-US" sz="1100" dirty="0"/>
+                  <a:t> sweep on real rosters</a:t>
                 </a:r>
               </a:p>
               <a:p>
@@ -6076,602 +6655,7 @@
                     <a:spcPct val="150000"/>
                   </a:lnSpc>
                 </a:pPr>
-                <a:r>
-                  <a:rPr lang="en-US" sz="1000" b="0" i="0" baseline="0" dirty="0">
-                    <a:latin typeface="Calibri"/>
-                  </a:rPr>
-                  <a:t>Block B — LG </a:t>
-                </a:r>
-                <a:r>
-                  <a:rPr lang="el-GR" sz="1000" b="0" i="0" baseline="0" dirty="0">
-                    <a:latin typeface="Calibri"/>
-                  </a:rPr>
-                  <a:t>ρ </a:t>
-                </a:r>
-                <a:r>
-                  <a:rPr lang="en-US" sz="1000" b="0" i="0" baseline="0" dirty="0">
-                    <a:latin typeface="Calibri"/>
-                  </a:rPr>
-                  <a:t>validation (ASSIGN readouts)</a:t>
-                </a:r>
-              </a:p>
-              <a:p>
-                <a:pPr lvl="1">
-                  <a:lnSpc>
-                    <a:spcPct val="150000"/>
-                  </a:lnSpc>
-                </a:pPr>
-                <a:r>
-                  <a:rPr lang="en-US" sz="1000" b="0" i="0" baseline="0" dirty="0">
-                    <a:latin typeface="Calibri"/>
-                  </a:rPr>
-                  <a:t>Slide 6 — LG ASSIGN: </a:t>
-                </a:r>
-                <a:r>
-                  <a:rPr lang="en-US" sz="1000" b="0" i="0" baseline="0" dirty="0" err="1">
-                    <a:latin typeface="Calibri"/>
-                  </a:rPr>
-                  <a:t>global_wss</a:t>
-                </a:r>
-                <a:r>
-                  <a:rPr lang="en-US" sz="1000" b="0" i="0" baseline="0" dirty="0">
-                    <a:latin typeface="Calibri"/>
-                  </a:rPr>
-                  <a:t> vs </a:t>
-                </a:r>
-                <a:r>
-                  <a:rPr lang="el-GR" sz="1000" b="0" i="0" baseline="0" dirty="0">
-                    <a:latin typeface="Calibri"/>
-                  </a:rPr>
-                  <a:t>ρ (</a:t>
-                </a:r>
-                <a:r>
-                  <a:rPr lang="en-US" sz="1000" b="0" i="0" baseline="0" dirty="0">
-                    <a:latin typeface="Calibri"/>
-                  </a:rPr>
-                  <a:t>primary)</a:t>
-                </a:r>
-              </a:p>
-              <a:p>
-                <a:pPr lvl="1">
-                  <a:lnSpc>
-                    <a:spcPct val="150000"/>
-                  </a:lnSpc>
-                </a:pPr>
-                <a:r>
-                  <a:rPr lang="en-US" sz="1000" b="0" i="0" baseline="0" dirty="0">
-                    <a:latin typeface="Calibri"/>
-                  </a:rPr>
-                  <a:t>Slide 7 — </a:t>
-                </a:r>
-                <a14:m>
-                  <m:oMath xmlns:m="http://schemas.openxmlformats.org/officeDocument/2006/math">
-                    <m:sSub>
-                      <m:sSubPr>
-                        <m:ctrlPr>
-                          <a:rPr lang="en-US" sz="1000" b="0" i="0" baseline="0" dirty="0" smtClean="0">
-                            <a:latin typeface="Cambria Math" panose="02040503050406030204" pitchFamily="18" charset="0"/>
-                          </a:rPr>
-                        </m:ctrlPr>
-                      </m:sSubPr>
-                      <m:e>
-                        <m:r>
-                          <a:rPr lang="en-US" sz="1000" b="0" i="0" baseline="0" dirty="0" smtClean="0">
-                            <a:latin typeface="Cambria Math" panose="02040503050406030204" pitchFamily="18" charset="0"/>
-                          </a:rPr>
-                          <m:t>𝐻</m:t>
-                        </m:r>
-                      </m:e>
-                      <m:sub>
-                        <m:r>
-                          <a:rPr lang="en-US" sz="1000" b="0" i="0" baseline="0" dirty="0" smtClean="0">
-                            <a:latin typeface="Cambria Math" panose="02040503050406030204" pitchFamily="18" charset="0"/>
-                          </a:rPr>
-                          <m:t>𝑠𝑜𝑟𝑡</m:t>
-                        </m:r>
-                      </m:sub>
-                    </m:sSub>
-                  </m:oMath>
-                </a14:m>
-                <a:r>
-                  <a:rPr lang="en-US" sz="1000" b="0" i="0" baseline="0" dirty="0">
-                    <a:latin typeface="Calibri"/>
-                  </a:rPr>
-                  <a:t> glossary + </a:t>
-                </a:r>
-                <a:r>
-                  <a:rPr lang="el-GR" sz="1000" b="0" i="0" baseline="0" dirty="0">
-                    <a:latin typeface="Calibri"/>
-                  </a:rPr>
-                  <a:t>ρ </a:t>
-                </a:r>
-                <a:r>
-                  <a:rPr lang="en-US" sz="1000" b="0" i="0" baseline="0" dirty="0">
-                    <a:latin typeface="Calibri"/>
-                  </a:rPr>
-                  <a:t>inset (companion)</a:t>
-                </a:r>
-              </a:p>
-              <a:p>
-                <a:pPr lvl="1">
-                  <a:lnSpc>
-                    <a:spcPct val="150000"/>
-                  </a:lnSpc>
-                </a:pPr>
-                <a:r>
-                  <a:rPr lang="en-US" sz="1000" b="0" i="0" baseline="0" dirty="0">
-                    <a:latin typeface="Calibri"/>
-                  </a:rPr>
-                  <a:t>Block C — Team </a:t>
-                </a:r>
-                <a14:m>
-                  <m:oMath xmlns:m="http://schemas.openxmlformats.org/officeDocument/2006/math">
-                    <m:sSub>
-                      <m:sSubPr>
-                        <m:ctrlPr>
-                          <a:rPr lang="en-US" sz="1000" b="0" i="0" baseline="0" dirty="0" smtClean="0">
-                            <a:latin typeface="Cambria Math" panose="02040503050406030204" pitchFamily="18" charset="0"/>
-                          </a:rPr>
-                        </m:ctrlPr>
-                      </m:sSubPr>
-                      <m:e>
-                        <m:r>
-                          <a:rPr lang="en-US" sz="1000" b="0" i="0" baseline="0" dirty="0" smtClean="0">
-                            <a:latin typeface="Cambria Math" panose="02040503050406030204" pitchFamily="18" charset="0"/>
-                          </a:rPr>
-                          <m:t>𝐿</m:t>
-                        </m:r>
-                      </m:e>
-                      <m:sub>
-                        <m:r>
-                          <a:rPr lang="en-US" sz="1000" b="0" i="0" baseline="0" dirty="0" smtClean="0">
-                            <a:latin typeface="Cambria Math" panose="02040503050406030204" pitchFamily="18" charset="0"/>
-                          </a:rPr>
-                          <m:t>𝐶</m:t>
-                        </m:r>
-                      </m:sub>
-                    </m:sSub>
-                  </m:oMath>
-                </a14:m>
-                <a:r>
-                  <a:rPr lang="en-US" sz="1000" b="0" i="0" baseline="0" dirty="0">
-                    <a:latin typeface="Calibri"/>
-                  </a:rPr>
-                  <a:t> (SCORE-side input, pre-SCORE)</a:t>
-                </a:r>
-              </a:p>
-              <a:p>
-                <a:pPr lvl="1">
-                  <a:lnSpc>
-                    <a:spcPct val="150000"/>
-                  </a:lnSpc>
-                </a:pPr>
-                <a:r>
-                  <a:rPr lang="en-US" sz="1000" b="0" i="0" baseline="0" dirty="0">
-                    <a:latin typeface="Calibri"/>
-                  </a:rPr>
-                  <a:t>Slide 8 — Empirical team </a:t>
-                </a:r>
-                <a14:m>
-                  <m:oMath xmlns:m="http://schemas.openxmlformats.org/officeDocument/2006/math">
-                    <m:sSub>
-                      <m:sSubPr>
-                        <m:ctrlPr>
-                          <a:rPr lang="en-US" sz="1000" b="0" i="0" baseline="0" dirty="0" smtClean="0">
-                            <a:latin typeface="Cambria Math" panose="02040503050406030204" pitchFamily="18" charset="0"/>
-                          </a:rPr>
-                        </m:ctrlPr>
-                      </m:sSubPr>
-                      <m:e>
-                        <m:r>
-                          <a:rPr lang="en-US" sz="1000" b="0" i="0" baseline="0" dirty="0" smtClean="0">
-                            <a:latin typeface="Cambria Math" panose="02040503050406030204" pitchFamily="18" charset="0"/>
-                          </a:rPr>
-                          <m:t>𝐿</m:t>
-                        </m:r>
-                      </m:e>
-                      <m:sub>
-                        <m:r>
-                          <a:rPr lang="en-US" sz="1000" b="0" i="0" baseline="0" dirty="0" smtClean="0">
-                            <a:latin typeface="Cambria Math" panose="02040503050406030204" pitchFamily="18" charset="0"/>
-                          </a:rPr>
-                          <m:t>𝐶</m:t>
-                        </m:r>
-                      </m:sub>
-                    </m:sSub>
-                  </m:oMath>
-                </a14:m>
-                <a:r>
-                  <a:rPr lang="en-US" sz="1000" b="0" i="0" baseline="0" dirty="0">
-                    <a:latin typeface="Calibri"/>
-                  </a:rPr>
-                  <a:t> distribution</a:t>
-                </a:r>
-              </a:p>
-              <a:p>
-                <a:pPr lvl="1">
-                  <a:lnSpc>
-                    <a:spcPct val="150000"/>
-                  </a:lnSpc>
-                </a:pPr>
-                <a:r>
-                  <a:rPr lang="en-US" sz="1000" b="0" i="0" baseline="0" dirty="0">
-                    <a:latin typeface="Calibri"/>
-                  </a:rPr>
-                  <a:t>Slides 9–11 — Empirical vs LG </a:t>
-                </a:r>
-                <a14:m>
-                  <m:oMath xmlns:m="http://schemas.openxmlformats.org/officeDocument/2006/math">
-                    <m:sSub>
-                      <m:sSubPr>
-                        <m:ctrlPr>
-                          <a:rPr lang="en-US" sz="1000" b="0" i="0" baseline="0" dirty="0" smtClean="0">
-                            <a:latin typeface="Cambria Math" panose="02040503050406030204" pitchFamily="18" charset="0"/>
-                          </a:rPr>
-                        </m:ctrlPr>
-                      </m:sSubPr>
-                      <m:e>
-                        <m:r>
-                          <a:rPr lang="en-US" sz="1000" b="0" i="0" baseline="0" dirty="0" smtClean="0">
-                            <a:latin typeface="Cambria Math" panose="02040503050406030204" pitchFamily="18" charset="0"/>
-                          </a:rPr>
-                          <m:t>𝐿</m:t>
-                        </m:r>
-                      </m:e>
-                      <m:sub>
-                        <m:r>
-                          <a:rPr lang="en-US" sz="1000" b="0" i="0" baseline="0" dirty="0" smtClean="0">
-                            <a:latin typeface="Cambria Math" panose="02040503050406030204" pitchFamily="18" charset="0"/>
-                          </a:rPr>
-                          <m:t>𝐶</m:t>
-                        </m:r>
-                      </m:sub>
-                    </m:sSub>
-                  </m:oMath>
-                </a14:m>
-                <a:r>
-                  <a:rPr lang="en-US" sz="1000" b="0" i="0" baseline="0" dirty="0">
-                    <a:latin typeface="Calibri"/>
-                  </a:rPr>
-                  <a:t> (raw · normalized · overlay)</a:t>
-                </a:r>
-              </a:p>
-              <a:p>
-                <a:pPr>
-                  <a:lnSpc>
-                    <a:spcPct val="150000"/>
-                  </a:lnSpc>
-                </a:pPr>
-                <a:r>
-                  <a:rPr lang="en-US" sz="1000" b="0" i="0" baseline="0" dirty="0">
-                    <a:latin typeface="Calibri"/>
-                  </a:rPr>
-                  <a:t>Block D — Alex comparability (inputs → SELECT)</a:t>
-                </a:r>
-              </a:p>
-              <a:p>
-                <a:pPr lvl="1">
-                  <a:lnSpc>
-                    <a:spcPct val="150000"/>
-                  </a:lnSpc>
-                </a:pPr>
-                <a:r>
-                  <a:rPr lang="en-US" sz="1000" b="0" i="0" baseline="0" dirty="0">
-                    <a:latin typeface="Calibri"/>
-                  </a:rPr>
-                  <a:t>Slide 12 — NCAA roster sizes vs fixed </a:t>
-                </a:r>
-                <a14:m>
-                  <m:oMath xmlns:m="http://schemas.openxmlformats.org/officeDocument/2006/math">
-                    <m:r>
-                      <a:rPr lang="en-US" sz="1000" b="0" i="0" baseline="0" dirty="0" smtClean="0">
-                        <a:latin typeface="Cambria Math" panose="02040503050406030204" pitchFamily="18" charset="0"/>
-                      </a:rPr>
-                      <m:t>𝐶</m:t>
-                    </m:r>
-                    <m:r>
-                      <a:rPr lang="en-US" sz="1000" b="0" i="0" baseline="0" dirty="0" smtClean="0">
-                        <a:latin typeface="Cambria Math" panose="02040503050406030204" pitchFamily="18" charset="0"/>
-                      </a:rPr>
-                      <m:t>=15</m:t>
-                    </m:r>
-                  </m:oMath>
-                </a14:m>
-                <a:endParaRPr lang="en-US" sz="1000" b="0" i="0" baseline="0" dirty="0">
-                  <a:latin typeface="Calibri"/>
-                </a:endParaRPr>
-              </a:p>
-              <a:p>
-                <a:pPr lvl="1">
-                  <a:lnSpc>
-                    <a:spcPct val="150000"/>
-                  </a:lnSpc>
-                </a:pPr>
-                <a:r>
-                  <a:rPr lang="en-US" sz="1000" b="0" i="0" baseline="0" dirty="0">
-                    <a:latin typeface="Calibri"/>
-                  </a:rPr>
-                  <a:t>Slides 13–14 — Hero min_minutes ladder (empirical inverted-U robust)</a:t>
-                </a:r>
-              </a:p>
-              <a:p>
-                <a:pPr lvl="1">
-                  <a:lnSpc>
-                    <a:spcPct val="150000"/>
-                  </a:lnSpc>
-                </a:pPr>
-                <a:r>
-                  <a:rPr lang="en-US" sz="1000" b="0" i="0" baseline="0" dirty="0">
-                    <a:latin typeface="Calibri"/>
-                  </a:rPr>
-                  <a:t>Slides 15–16 — LG capacity sweep: </a:t>
-                </a:r>
-                <a14:m>
-                  <m:oMath xmlns:m="http://schemas.openxmlformats.org/officeDocument/2006/math">
-                    <m:sSub>
-                      <m:sSubPr>
-                        <m:ctrlPr>
-                          <a:rPr lang="en-US" sz="1000" b="0" i="0" baseline="0" dirty="0" smtClean="0">
-                            <a:latin typeface="Cambria Math" panose="02040503050406030204" pitchFamily="18" charset="0"/>
-                          </a:rPr>
-                        </m:ctrlPr>
-                      </m:sSubPr>
-                      <m:e>
-                        <m:r>
-                          <a:rPr lang="en-US" sz="1000" b="0" i="0" baseline="0" dirty="0" smtClean="0">
-                            <a:latin typeface="Cambria Math" panose="02040503050406030204" pitchFamily="18" charset="0"/>
-                          </a:rPr>
-                          <m:t>𝐿</m:t>
-                        </m:r>
-                      </m:e>
-                      <m:sub>
-                        <m:r>
-                          <a:rPr lang="en-US" sz="1000" b="0" i="0" baseline="0" dirty="0" smtClean="0">
-                            <a:latin typeface="Cambria Math" panose="02040503050406030204" pitchFamily="18" charset="0"/>
-                          </a:rPr>
-                          <m:t>𝐶</m:t>
-                        </m:r>
-                      </m:sub>
-                    </m:sSub>
-                  </m:oMath>
-                </a14:m>
-                <a:r>
-                  <a:rPr lang="en-US" sz="1000" b="0" i="0" baseline="0" dirty="0">
-                    <a:latin typeface="Calibri"/>
-                  </a:rPr>
-                  <a:t> vs NCAA · SELECT vs Hero</a:t>
-                </a:r>
-              </a:p>
-              <a:p>
-                <a:pPr lvl="1">
-                  <a:lnSpc>
-                    <a:spcPct val="150000"/>
-                  </a:lnSpc>
-                </a:pPr>
-                <a:r>
-                  <a:rPr lang="en-US" sz="1000" b="0" i="0" baseline="0" dirty="0">
-                    <a:latin typeface="Calibri"/>
-                  </a:rPr>
-                  <a:t>Slide 17 — Empirical roster-size multiset (Alex caps fix)</a:t>
-                </a:r>
-              </a:p>
-              <a:p>
-                <a:pPr lvl="1">
-                  <a:lnSpc>
-                    <a:spcPct val="150000"/>
-                  </a:lnSpc>
-                </a:pPr>
-                <a:r>
-                  <a:rPr lang="en-US" sz="1000" b="0" i="0" baseline="0" dirty="0">
-                    <a:latin typeface="Calibri"/>
-                  </a:rPr>
-                  <a:t>Slides 18–19 — Empirical caps: </a:t>
-                </a:r>
-                <a14:m>
-                  <m:oMath xmlns:m="http://schemas.openxmlformats.org/officeDocument/2006/math">
-                    <m:sSub>
-                      <m:sSubPr>
-                        <m:ctrlPr>
-                          <a:rPr lang="en-US" sz="1000" b="0" i="0" baseline="0" dirty="0" smtClean="0">
-                            <a:latin typeface="Cambria Math" panose="02040503050406030204" pitchFamily="18" charset="0"/>
-                          </a:rPr>
-                        </m:ctrlPr>
-                      </m:sSubPr>
-                      <m:e>
-                        <m:r>
-                          <a:rPr lang="en-US" sz="1000" b="0" i="0" baseline="0" dirty="0" smtClean="0">
-                            <a:latin typeface="Cambria Math" panose="02040503050406030204" pitchFamily="18" charset="0"/>
-                          </a:rPr>
-                          <m:t>𝐿</m:t>
-                        </m:r>
-                      </m:e>
-                      <m:sub>
-                        <m:r>
-                          <a:rPr lang="en-US" sz="1000" b="0" i="0" baseline="0" dirty="0" smtClean="0">
-                            <a:latin typeface="Cambria Math" panose="02040503050406030204" pitchFamily="18" charset="0"/>
-                          </a:rPr>
-                          <m:t>𝐶</m:t>
-                        </m:r>
-                      </m:sub>
-                    </m:sSub>
-                  </m:oMath>
-                </a14:m>
-                <a:r>
-                  <a:rPr lang="en-US" sz="1000" b="0" i="0" baseline="0" dirty="0">
-                    <a:latin typeface="Calibri"/>
-                  </a:rPr>
-                  <a:t> vs NCAA · SELECT vs Hero</a:t>
-                </a:r>
-              </a:p>
-              <a:p>
-                <a:pPr>
-                  <a:lnSpc>
-                    <a:spcPct val="150000"/>
-                  </a:lnSpc>
-                </a:pPr>
-                <a:r>
-                  <a:rPr lang="en-US" sz="1000" b="0" i="0" baseline="0" dirty="0">
-                    <a:latin typeface="Calibri"/>
-                  </a:rPr>
-                  <a:t>Block E — SCORE-side empirical (PD17)</a:t>
-                </a:r>
-              </a:p>
-              <a:p>
-                <a:pPr lvl="1">
-                  <a:lnSpc>
-                    <a:spcPct val="150000"/>
-                  </a:lnSpc>
-                </a:pPr>
-                <a:r>
-                  <a:rPr lang="en-US" sz="1000" b="0" i="0" baseline="0" dirty="0">
-                    <a:latin typeface="Calibri"/>
-                  </a:rPr>
-                  <a:t>Slide 20 — Sketch A: </a:t>
-                </a:r>
-                <a14:m>
-                  <m:oMath xmlns:m="http://schemas.openxmlformats.org/officeDocument/2006/math">
-                    <m:r>
-                      <a:rPr lang="en-US" sz="1000" b="0" i="0" baseline="0" dirty="0" smtClean="0">
-                        <a:latin typeface="Cambria Math" panose="02040503050406030204" pitchFamily="18" charset="0"/>
-                      </a:rPr>
-                      <m:t>𝑇</m:t>
-                    </m:r>
-                    <m:sSub>
-                      <m:sSubPr>
-                        <m:ctrlPr>
-                          <a:rPr lang="en-US" sz="1000" b="0" i="0" baseline="0" dirty="0" err="1" smtClean="0">
-                            <a:latin typeface="Cambria Math" panose="02040503050406030204" pitchFamily="18" charset="0"/>
-                          </a:rPr>
-                        </m:ctrlPr>
-                      </m:sSubPr>
-                      <m:e>
-                        <m:r>
-                          <a:rPr lang="en-US" sz="1000" b="0" i="0" baseline="0" dirty="0" err="1" smtClean="0">
-                            <a:latin typeface="Cambria Math" panose="02040503050406030204" pitchFamily="18" charset="0"/>
-                          </a:rPr>
-                          <m:t>̂</m:t>
-                        </m:r>
-                      </m:e>
-                      <m:sub>
-                        <m:r>
-                          <a:rPr lang="en-US" sz="1000" b="0" i="0" baseline="0" dirty="0" err="1" smtClean="0">
-                            <a:latin typeface="Cambria Math" panose="02040503050406030204" pitchFamily="18" charset="0"/>
-                          </a:rPr>
-                          <m:t>𝑗</m:t>
-                        </m:r>
-                      </m:sub>
-                    </m:sSub>
-                  </m:oMath>
-                </a14:m>
-                <a:r>
-                  <a:rPr lang="en-US" sz="1000" b="0" i="0" baseline="0" dirty="0">
-                    <a:latin typeface="Calibri"/>
-                  </a:rPr>
-                  <a:t> vs </a:t>
-                </a:r>
-                <a14:m>
-                  <m:oMath xmlns:m="http://schemas.openxmlformats.org/officeDocument/2006/math">
-                    <m:sSub>
-                      <m:sSubPr>
-                        <m:ctrlPr>
-                          <a:rPr lang="en-US" sz="1000" b="0" i="0" baseline="0" dirty="0" smtClean="0">
-                            <a:latin typeface="Cambria Math" panose="02040503050406030204" pitchFamily="18" charset="0"/>
-                          </a:rPr>
-                        </m:ctrlPr>
-                      </m:sSubPr>
-                      <m:e>
-                        <m:r>
-                          <a:rPr lang="en-US" sz="1000" b="0" i="0" baseline="0" dirty="0" smtClean="0">
-                            <a:latin typeface="Cambria Math" panose="02040503050406030204" pitchFamily="18" charset="0"/>
-                          </a:rPr>
-                          <m:t>𝐿</m:t>
-                        </m:r>
-                      </m:e>
-                      <m:sub>
-                        <m:r>
-                          <a:rPr lang="en-US" sz="1000" b="0" i="0" baseline="0" dirty="0" smtClean="0">
-                            <a:latin typeface="Cambria Math" panose="02040503050406030204" pitchFamily="18" charset="0"/>
-                          </a:rPr>
-                          <m:t>𝐶</m:t>
-                        </m:r>
-                      </m:sub>
-                    </m:sSub>
-                  </m:oMath>
-                </a14:m>
-                <a:endParaRPr lang="en-US" sz="1000" b="0" i="0" baseline="0" dirty="0">
-                  <a:latin typeface="Calibri"/>
-                </a:endParaRPr>
-              </a:p>
-              <a:p>
-                <a:pPr lvl="1">
-                  <a:lnSpc>
-                    <a:spcPct val="150000"/>
-                  </a:lnSpc>
-                </a:pPr>
-                <a:r>
-                  <a:rPr lang="en-US" sz="1000" b="0" i="0" baseline="0" dirty="0">
-                    <a:latin typeface="Calibri"/>
-                  </a:rPr>
-                  <a:t>Slide 21 — </a:t>
-                </a:r>
-                <a:r>
-                  <a:rPr lang="el-GR" sz="1000" b="0" i="0" baseline="0" dirty="0">
-                    <a:latin typeface="Calibri"/>
-                  </a:rPr>
-                  <a:t>γ </a:t>
-                </a:r>
-                <a:r>
-                  <a:rPr lang="en-US" sz="1000" b="0" i="0" baseline="0" dirty="0">
-                    <a:latin typeface="Calibri"/>
-                  </a:rPr>
-                  <a:t>sweep on real rosters</a:t>
-                </a:r>
-              </a:p>
-              <a:p>
-                <a:pPr>
-                  <a:lnSpc>
-                    <a:spcPct val="150000"/>
-                  </a:lnSpc>
-                </a:pPr>
-                <a:r>
-                  <a:rPr lang="en-US" sz="1000" b="0" i="0" baseline="0" dirty="0">
-                    <a:latin typeface="Calibri"/>
-                  </a:rPr>
-                  <a:t>Appendix</a:t>
-                </a:r>
-              </a:p>
-              <a:p>
-                <a:pPr lvl="1">
-                  <a:lnSpc>
-                    <a:spcPct val="150000"/>
-                  </a:lnSpc>
-                </a:pPr>
-                <a:r>
-                  <a:rPr lang="en-US" sz="1000" b="0" i="0" baseline="0" dirty="0">
-                    <a:latin typeface="Calibri"/>
-                  </a:rPr>
-                  <a:t>Slide 22 — 539 </a:t>
-                </a:r>
-                <a:r>
-                  <a:rPr lang="el-GR" sz="1000" b="0" i="0" baseline="0" dirty="0">
-                    <a:latin typeface="Calibri"/>
-                  </a:rPr>
-                  <a:t>ρ </a:t>
-                </a:r>
-                <a:r>
-                  <a:rPr lang="en-US" sz="1000" b="0" i="0" baseline="0" dirty="0">
-                    <a:latin typeface="Calibri"/>
-                  </a:rPr>
-                  <a:t>calibration capstone (legacy sim axes)</a:t>
-                </a:r>
-              </a:p>
-              <a:p>
-                <a:pPr>
-                  <a:lnSpc>
-                    <a:spcPct val="150000"/>
-                  </a:lnSpc>
-                </a:pPr>
-                <a:endParaRPr sz="1000" b="0" i="0" baseline="0" dirty="0">
+                <a:endParaRPr sz="500" b="0" i="0" baseline="0" dirty="0">
                   <a:latin typeface="Calibri"/>
                 </a:endParaRPr>
               </a:p>
@@ -6695,8 +6679,8 @@
             </p:nvSpPr>
             <p:spPr>
               <a:xfrm>
-                <a:off x="6984337" y="1264044"/>
-                <a:ext cx="4411913" cy="5146794"/>
+                <a:off x="6908535" y="1393171"/>
+                <a:ext cx="4411913" cy="4089196"/>
               </a:xfrm>
               <a:prstGeom prst="rect">
                 <a:avLst/>
@@ -6723,8 +6707,8 @@
           </p:sp>
         </mc:Fallback>
       </mc:AlternateContent>
-      <mc:AlternateContent xmlns:mc="http://schemas.openxmlformats.org/markup-compatibility/2006" xmlns:a14="http://schemas.microsoft.com/office/drawing/2010/main">
-        <mc:Choice Requires="a14">
+      <mc:AlternateContent xmlns:mc="http://schemas.openxmlformats.org/markup-compatibility/2006">
+        <mc:Choice xmlns:a14="http://schemas.microsoft.com/office/drawing/2010/main" Requires="a14">
           <p:sp>
             <p:nvSpPr>
               <p:cNvPr id="11" name="TextBox 10">
@@ -6753,17 +6737,20 @@
               </a:bodyPr>
               <a:lstStyle/>
               <a:p>
-                <a:pPr algn="l"/>
                 <a:r>
                   <a:rPr sz="1100" b="1" i="0" baseline="0" dirty="0">
                     <a:latin typeface="Calibri"/>
                   </a:rPr>
-                  <a:t>Claim (PD17): Map empirical properties of real rosters — prerequisite for pinning </a:t>
-                </a:r>
-                <a14:m>
-                  <m:oMath xmlns:m="http://schemas.openxmlformats.org/officeDocument/2006/math">
-                    <m:r>
-                      <a:rPr lang="en-US" sz="1100" b="1" i="0" baseline="0" dirty="0" smtClean="0">
+                  <a:t>Claim (PD17): </a:t>
+                </a:r>
+                <a:r>
+                  <a:rPr lang="en-US" sz="1100" dirty="0"/>
+                  <a:t>Map empirical roster geometry; validate </a:t>
+                </a:r>
+                <a14:m>
+                  <m:oMath xmlns:m="http://schemas.openxmlformats.org/officeDocument/2006/math">
+                    <m:r>
+                      <a:rPr lang="en-US" sz="1100" i="1" dirty="0" smtClean="0">
                         <a:latin typeface="Cambria Math" panose="02040503050406030204" pitchFamily="18" charset="0"/>
                       </a:rPr>
                       <m:t>𝜌</m:t>
@@ -6771,47 +6758,17 @@
                   </m:oMath>
                 </a14:m>
                 <a:r>
-                  <a:rPr sz="1100" b="1" i="0" baseline="0" dirty="0">
-                    <a:latin typeface="Calibri"/>
-                  </a:rPr>
-                  <a:t> and </a:t>
-                </a:r>
-                <a14:m>
-                  <m:oMath xmlns:m="http://schemas.openxmlformats.org/officeDocument/2006/math">
-                    <m:r>
-                      <a:rPr lang="en-US" sz="1100" b="1" i="0" baseline="0" dirty="0" smtClean="0">
-                        <a:latin typeface="Cambria Math" panose="02040503050406030204" pitchFamily="18" charset="0"/>
-                      </a:rPr>
-                      <m:t>𝜃</m:t>
-                    </m:r>
-                  </m:oMath>
-                </a14:m>
-                <a:r>
-                  <a:rPr sz="1100" b="1" i="0" baseline="0" dirty="0">
-                    <a:latin typeface="Calibri"/>
-                  </a:rPr>
-                  <a:t> from data, then </a:t>
-                </a:r>
-                <a14:m>
-                  <m:oMath xmlns:m="http://schemas.openxmlformats.org/officeDocument/2006/math">
-                    <m:r>
-                      <a:rPr lang="en-US" sz="1100" b="1" i="0" baseline="0" dirty="0" smtClean="0">
-                        <a:latin typeface="Cambria Math" panose="02040503050406030204" pitchFamily="18" charset="0"/>
-                      </a:rPr>
-                      <m:t>𝛾</m:t>
-                    </m:r>
-                  </m:oMath>
-                </a14:m>
-                <a:r>
-                  <a:rPr sz="1100" b="1" i="0" baseline="0" dirty="0">
-                    <a:latin typeface="Calibri"/>
-                  </a:rPr>
-                  <a:t> and </a:t>
-                </a:r>
-                <a14:m>
-                  <m:oMath xmlns:m="http://schemas.openxmlformats.org/officeDocument/2006/math">
-                    <m:r>
-                      <a:rPr lang="en-US" sz="1100" b="1" i="0" baseline="0" dirty="0" smtClean="0">
+                  <a:rPr lang="en-US" sz="1100" dirty="0"/>
+                  <a:t> on ASSIGN; with caps fixed, </a:t>
+                </a:r>
+                <a:r>
+                  <a:rPr lang="en-US" sz="1100" b="1" dirty="0"/>
+                  <a:t>Hero shape on LOO emerges in LG via </a:t>
+                </a:r>
+                <a14:m>
+                  <m:oMath xmlns:m="http://schemas.openxmlformats.org/officeDocument/2006/math">
+                    <m:r>
+                      <a:rPr lang="en-US" sz="1100" b="1" i="1" dirty="0" smtClean="0">
                         <a:latin typeface="Cambria Math" panose="02040503050406030204" pitchFamily="18" charset="0"/>
                       </a:rPr>
                       <m:t>𝜆</m:t>
@@ -6819,16 +6776,35 @@
                   </m:oMath>
                 </a14:m>
                 <a:r>
-                  <a:rPr sz="1100" b="1" i="0" baseline="0" dirty="0">
-                    <a:latin typeface="Calibri"/>
-                  </a:rPr>
-                  <a:t> without hero-curve matching.</a:t>
-                </a:r>
+                  <a:rPr lang="en-US" sz="1100" b="1" dirty="0"/>
+                  <a:t> in SCORE</a:t>
+                </a:r>
+                <a:r>
+                  <a:rPr lang="en-US" sz="1100" dirty="0"/>
+                  <a:t> (slides 20–21) — not via </a:t>
+                </a:r>
+                <a14:m>
+                  <m:oMath xmlns:m="http://schemas.openxmlformats.org/officeDocument/2006/math">
+                    <m:r>
+                      <a:rPr lang="en-US" sz="1100" i="1" dirty="0" smtClean="0">
+                        <a:latin typeface="Cambria Math" panose="02040503050406030204" pitchFamily="18" charset="0"/>
+                      </a:rPr>
+                      <m:t>𝜌</m:t>
+                    </m:r>
+                  </m:oMath>
+                </a14:m>
+                <a:r>
+                  <a:rPr lang="en-US" sz="1100" dirty="0"/>
+                  <a:t> or roster alignment alone.</a:t>
+                </a:r>
+                <a:endParaRPr sz="1100" b="1" i="0" baseline="0" dirty="0">
+                  <a:latin typeface="Calibri"/>
+                </a:endParaRPr>
               </a:p>
             </p:txBody>
           </p:sp>
         </mc:Choice>
-        <mc:Fallback xmlns="">
+        <mc:Fallback>
           <p:sp>
             <p:nvSpPr>
               <p:cNvPr id="11" name="TextBox 10">

</xml_diff>